<commit_message>
Publish final submission package
</commit_message>
<xml_diff>
--- a/VPorkPay-Final-Submission-Deck.pptx
+++ b/VPorkPay-Final-Submission-Deck.pptx
@@ -2,20 +2,20 @@
 <file path=ppt/presentation.xml><?xml version="1.0" encoding="utf-8"?>
 <p:presentation xmlns:p="http://schemas.openxmlformats.org/presentationml/2006/main">
   <p:sldMasterIdLst>
-    <p:sldMasterId xmlns:r="http://schemas.openxmlformats.org/officeDocument/2006/relationships" id="2147483648" r:id="Rcc2282a1ce7344dd"/>
+    <p:sldMasterId xmlns:r="http://schemas.openxmlformats.org/officeDocument/2006/relationships" id="2147483648" r:id="Rb24d1a45acd94434"/>
   </p:sldMasterIdLst>
   <p:notesMasterIdLst>
-    <p:notesMasterId xmlns:r="http://schemas.openxmlformats.org/officeDocument/2006/relationships" r:id="Rd0b91277520743ee"/>
+    <p:notesMasterId xmlns:r="http://schemas.openxmlformats.org/officeDocument/2006/relationships" r:id="R0734db42ff9f4949"/>
   </p:notesMasterIdLst>
   <p:sldIdLst>
-    <p:sldId xmlns:r="http://schemas.openxmlformats.org/officeDocument/2006/relationships" id="256" r:id="R3626f8eb234e40bc"/>
-    <p:sldId xmlns:r="http://schemas.openxmlformats.org/officeDocument/2006/relationships" id="257" r:id="Re01a008f29374279"/>
-    <p:sldId xmlns:r="http://schemas.openxmlformats.org/officeDocument/2006/relationships" id="258" r:id="R2095240aa3b34aa9"/>
-    <p:sldId xmlns:r="http://schemas.openxmlformats.org/officeDocument/2006/relationships" id="259" r:id="R98068efc47374114"/>
-    <p:sldId xmlns:r="http://schemas.openxmlformats.org/officeDocument/2006/relationships" id="260" r:id="R9695cdc18fe444c2"/>
-    <p:sldId xmlns:r="http://schemas.openxmlformats.org/officeDocument/2006/relationships" id="261" r:id="R3e2af4a938f4451b"/>
-    <p:sldId xmlns:r="http://schemas.openxmlformats.org/officeDocument/2006/relationships" id="262" r:id="Rf7d2dff85c1e4645"/>
-    <p:sldId xmlns:r="http://schemas.openxmlformats.org/officeDocument/2006/relationships" id="263" r:id="Ra8d5c6b61d7442e7"/>
+    <p:sldId xmlns:r="http://schemas.openxmlformats.org/officeDocument/2006/relationships" id="256" r:id="Rfc808a337539427c"/>
+    <p:sldId xmlns:r="http://schemas.openxmlformats.org/officeDocument/2006/relationships" id="257" r:id="R0cf34c7c2945459c"/>
+    <p:sldId xmlns:r="http://schemas.openxmlformats.org/officeDocument/2006/relationships" id="258" r:id="R272d625ae14848b6"/>
+    <p:sldId xmlns:r="http://schemas.openxmlformats.org/officeDocument/2006/relationships" id="259" r:id="Rb80fed516c0645cf"/>
+    <p:sldId xmlns:r="http://schemas.openxmlformats.org/officeDocument/2006/relationships" id="260" r:id="Rc155f73f9eb34e7e"/>
+    <p:sldId xmlns:r="http://schemas.openxmlformats.org/officeDocument/2006/relationships" id="261" r:id="R94715ced503d47bb"/>
+    <p:sldId xmlns:r="http://schemas.openxmlformats.org/officeDocument/2006/relationships" id="262" r:id="Rdae499159fc6458b"/>
+    <p:sldId xmlns:r="http://schemas.openxmlformats.org/officeDocument/2006/relationships" id="263" r:id="R2ded5fd3a45e49e8"/>
   </p:sldIdLst>
   <p:sldSz cx="12192000" cy="6858000"/>
   <p:notesSz cx="6858000" cy="9144000"/>
@@ -1159,6 +1159,11 @@
           </a:p>
           <a:p xmlns:a="http://schemas.openxmlformats.org/drawingml/2006/main">
             <a:r>
+              <a:t>- https://vybao39-rgb.github.io/porkpay/VPorkPay-Final-Demo.mp4</a:t>
+            </a:r>
+          </a:p>
+          <a:p xmlns:a="http://schemas.openxmlformats.org/drawingml/2006/main">
+            <a:r>
               <a:t>- https://vybao39-rgb.github.io/porkpay/presentation.html</a:t>
             </a:r>
           </a:p>
@@ -1237,7 +1242,7 @@
   </p:cSld>
   <p:clrMap bg1="lt1" tx1="dk1" bg2="lt2" tx2="dk2" accent1="accent1" accent2="accent2" accent3="accent3" accent4="accent4" accent5="accent5" accent6="accent6" hlink="hlink" folHlink="folHlink"/>
   <p:sldLayoutIdLst>
-    <p:sldLayoutId xmlns:r="http://schemas.openxmlformats.org/officeDocument/2006/relationships" id="2147483649" r:id="R7da24e5332fa4f0f"/>
+    <p:sldLayoutId xmlns:r="http://schemas.openxmlformats.org/officeDocument/2006/relationships" id="2147483649" r:id="R522d9018b66649da"/>
   </p:sldLayoutIdLst>
   <p:txStyles>
     <p:titleStyle>
@@ -1823,7 +1828,7 @@
           <p:nvPr/>
         </p:nvPicPr>
         <p:blipFill>
-          <a:blip xmlns:r="http://schemas.openxmlformats.org/officeDocument/2006/relationships" xmlns:a="http://schemas.openxmlformats.org/drawingml/2006/main" r:embed="R0d87e398957e4d8c"/>
+          <a:blip xmlns:r="http://schemas.openxmlformats.org/officeDocument/2006/relationships" xmlns:a="http://schemas.openxmlformats.org/drawingml/2006/main" r:embed="R3244e25a64324de4"/>
           <a:srcRect xmlns:a="http://schemas.openxmlformats.org/drawingml/2006/main" l="90" t="0" r="90" b="0"/>
           <a:stretch xmlns:a="http://schemas.openxmlformats.org/drawingml/2006/main">
             <a:fillRect l="0" t="0" r="0" b="0"/>
@@ -1850,7 +1855,7 @@
           <p:nvPr/>
         </p:nvPicPr>
         <p:blipFill>
-          <a:blip xmlns:r="http://schemas.openxmlformats.org/officeDocument/2006/relationships" xmlns:a="http://schemas.openxmlformats.org/drawingml/2006/main" r:embed="Rd402088505b4425e"/>
+          <a:blip xmlns:r="http://schemas.openxmlformats.org/officeDocument/2006/relationships" xmlns:a="http://schemas.openxmlformats.org/drawingml/2006/main" r:embed="R06a926b3b1e84208"/>
           <a:srcRect xmlns:a="http://schemas.openxmlformats.org/drawingml/2006/main" l="0" t="10317" r="0" b="10317"/>
           <a:stretch xmlns:a="http://schemas.openxmlformats.org/drawingml/2006/main">
             <a:fillRect l="0" t="0" r="0" b="0"/>
@@ -2834,7 +2839,7 @@
           <p:nvPr/>
         </p:nvPicPr>
         <p:blipFill>
-          <a:blip xmlns:r="http://schemas.openxmlformats.org/officeDocument/2006/relationships" xmlns:a="http://schemas.openxmlformats.org/drawingml/2006/main" r:embed="R86e452b214334ccd"/>
+          <a:blip xmlns:r="http://schemas.openxmlformats.org/officeDocument/2006/relationships" xmlns:a="http://schemas.openxmlformats.org/drawingml/2006/main" r:embed="R46864cf4b6554dfd"/>
           <a:srcRect xmlns:a="http://schemas.openxmlformats.org/drawingml/2006/main" l="25000" t="0" r="25000" b="0"/>
           <a:stretch xmlns:a="http://schemas.openxmlformats.org/drawingml/2006/main">
             <a:fillRect l="0" t="0" r="0" b="0"/>
@@ -2861,7 +2866,7 @@
           <p:nvPr/>
         </p:nvPicPr>
         <p:blipFill>
-          <a:blip xmlns:r="http://schemas.openxmlformats.org/officeDocument/2006/relationships" xmlns:a="http://schemas.openxmlformats.org/drawingml/2006/main" r:embed="Rc7671f4c4634439d"/>
+          <a:blip xmlns:r="http://schemas.openxmlformats.org/officeDocument/2006/relationships" xmlns:a="http://schemas.openxmlformats.org/drawingml/2006/main" r:embed="R3a4bcb9f52754ab1"/>
           <a:srcRect xmlns:a="http://schemas.openxmlformats.org/drawingml/2006/main" l="20682" t="0" r="20682" b="0"/>
           <a:stretch xmlns:a="http://schemas.openxmlformats.org/drawingml/2006/main">
             <a:fillRect l="0" t="0" r="0" b="0"/>
@@ -3246,7 +3251,7 @@
           <p:nvPr/>
         </p:nvPicPr>
         <p:blipFill>
-          <a:blip xmlns:r="http://schemas.openxmlformats.org/officeDocument/2006/relationships" xmlns:a="http://schemas.openxmlformats.org/drawingml/2006/main" r:embed="R4727a63acd8c4ff4"/>
+          <a:blip xmlns:r="http://schemas.openxmlformats.org/officeDocument/2006/relationships" xmlns:a="http://schemas.openxmlformats.org/drawingml/2006/main" r:embed="R152b62580db74fd8"/>
           <a:srcRect xmlns:a="http://schemas.openxmlformats.org/drawingml/2006/main" l="9628" t="0" r="9628" b="0"/>
           <a:stretch xmlns:a="http://schemas.openxmlformats.org/drawingml/2006/main">
             <a:fillRect l="0" t="0" r="0" b="0"/>
@@ -4150,7 +4155,7 @@
           <p:nvPr/>
         </p:nvPicPr>
         <p:blipFill>
-          <a:blip xmlns:r="http://schemas.openxmlformats.org/officeDocument/2006/relationships" xmlns:a="http://schemas.openxmlformats.org/drawingml/2006/main" r:embed="R2415314f2dce43a1"/>
+          <a:blip xmlns:r="http://schemas.openxmlformats.org/officeDocument/2006/relationships" xmlns:a="http://schemas.openxmlformats.org/drawingml/2006/main" r:embed="R9d766b9dc05d424e"/>
           <a:srcRect xmlns:a="http://schemas.openxmlformats.org/drawingml/2006/main" l="0" t="2357" r="0" b="2357"/>
           <a:stretch xmlns:a="http://schemas.openxmlformats.org/drawingml/2006/main">
             <a:fillRect l="0" t="0" r="0" b="0"/>
@@ -8517,7 +8522,7 @@
           <p:nvPr/>
         </p:nvPicPr>
         <p:blipFill>
-          <a:blip xmlns:r="http://schemas.openxmlformats.org/officeDocument/2006/relationships" xmlns:a="http://schemas.openxmlformats.org/drawingml/2006/main" r:embed="Ra4ad145752de412e"/>
+          <a:blip xmlns:r="http://schemas.openxmlformats.org/officeDocument/2006/relationships" xmlns:a="http://schemas.openxmlformats.org/drawingml/2006/main" r:embed="Re00dea17d15540b5"/>
           <a:srcRect xmlns:a="http://schemas.openxmlformats.org/drawingml/2006/main" l="0" t="27273" r="0" b="27273"/>
           <a:stretch xmlns:a="http://schemas.openxmlformats.org/drawingml/2006/main">
             <a:fillRect l="0" t="0" r="0" b="0"/>
@@ -8810,7 +8815,7 @@
           <p:nvPr/>
         </p:nvPicPr>
         <p:blipFill>
-          <a:blip xmlns:r="http://schemas.openxmlformats.org/officeDocument/2006/relationships" xmlns:a="http://schemas.openxmlformats.org/drawingml/2006/main" r:embed="R8a35be46e96b4b06"/>
+          <a:blip xmlns:r="http://schemas.openxmlformats.org/officeDocument/2006/relationships" xmlns:a="http://schemas.openxmlformats.org/drawingml/2006/main" r:embed="Rc4e58b994a6746f7"/>
           <a:srcRect xmlns:a="http://schemas.openxmlformats.org/drawingml/2006/main" l="23437" t="0" r="23437" b="0"/>
           <a:stretch xmlns:a="http://schemas.openxmlformats.org/drawingml/2006/main">
             <a:fillRect l="0" t="0" r="0" b="0"/>
@@ -9155,7 +9160,7 @@
                 <a:solidFill>
                   <a:srgbClr val="FFFFFF"/>
                 </a:solidFill>
-                <a:hlinkClick xmlns:r="http://schemas.openxmlformats.org/officeDocument/2006/relationships" r:id="R4b26d8b6c13a41fa"/>
+                <a:hlinkClick xmlns:r="http://schemas.openxmlformats.org/officeDocument/2006/relationships" r:id="R3b774a2f311a4180"/>
               </a:rPr>
               <a:t>Public GitHub repository</a:t>
             </a:r>
@@ -9258,7 +9263,7 @@
                 <a:solidFill>
                   <a:srgbClr val="FFFFFF"/>
                 </a:solidFill>
-                <a:hlinkClick xmlns:r="http://schemas.openxmlformats.org/officeDocument/2006/relationships" r:id="Ra4dab72528344d90"/>
+                <a:hlinkClick xmlns:r="http://schemas.openxmlformats.org/officeDocument/2006/relationships" r:id="R268a18a060b64286"/>
               </a:rPr>
               <a:t>Functional GitHub Pages MVP</a:t>
             </a:r>
@@ -9311,7 +9316,7 @@
                   <a:srgbClr val="171712"/>
                 </a:solidFill>
               </a:rPr>
-              <a:t>DECK</a:t>
+              <a:t>VIDEO</a:t>
             </a:r>
           </a:p>
         </p:txBody>
@@ -9361,9 +9366,9 @@
                 <a:solidFill>
                   <a:srgbClr val="FFFFFF"/>
                 </a:solidFill>
-                <a:hlinkClick xmlns:r="http://schemas.openxmlformats.org/officeDocument/2006/relationships" r:id="Rcd26c63924ed4cd2"/>
-              </a:rPr>
-              <a:t>Interactive final presentation</a:t>
+                <a:hlinkClick xmlns:r="http://schemas.openxmlformats.org/officeDocument/2006/relationships" r:id="R4772acaa18c44c7c"/>
+              </a:rPr>
+              <a:t>3-minute pitch and demo</a:t>
             </a:r>
           </a:p>
         </p:txBody>

</xml_diff>

<commit_message>
Publish verified Arc contract deployment
</commit_message>
<xml_diff>
--- a/VPorkPay-Final-Submission-Deck.pptx
+++ b/VPorkPay-Final-Submission-Deck.pptx
@@ -2,20 +2,20 @@
 <file path=ppt/presentation.xml><?xml version="1.0" encoding="utf-8"?>
 <p:presentation xmlns:p="http://schemas.openxmlformats.org/presentationml/2006/main">
   <p:sldMasterIdLst>
-    <p:sldMasterId xmlns:r="http://schemas.openxmlformats.org/officeDocument/2006/relationships" id="2147483648" r:id="Rb24d1a45acd94434"/>
+    <p:sldMasterId xmlns:r="http://schemas.openxmlformats.org/officeDocument/2006/relationships" id="2147483648" r:id="R8bcebc93256d4b8a"/>
   </p:sldMasterIdLst>
   <p:notesMasterIdLst>
-    <p:notesMasterId xmlns:r="http://schemas.openxmlformats.org/officeDocument/2006/relationships" r:id="R0734db42ff9f4949"/>
+    <p:notesMasterId xmlns:r="http://schemas.openxmlformats.org/officeDocument/2006/relationships" r:id="Rabd9934d54b84a6d"/>
   </p:notesMasterIdLst>
   <p:sldIdLst>
-    <p:sldId xmlns:r="http://schemas.openxmlformats.org/officeDocument/2006/relationships" id="256" r:id="Rfc808a337539427c"/>
-    <p:sldId xmlns:r="http://schemas.openxmlformats.org/officeDocument/2006/relationships" id="257" r:id="R0cf34c7c2945459c"/>
-    <p:sldId xmlns:r="http://schemas.openxmlformats.org/officeDocument/2006/relationships" id="258" r:id="R272d625ae14848b6"/>
-    <p:sldId xmlns:r="http://schemas.openxmlformats.org/officeDocument/2006/relationships" id="259" r:id="Rb80fed516c0645cf"/>
-    <p:sldId xmlns:r="http://schemas.openxmlformats.org/officeDocument/2006/relationships" id="260" r:id="Rc155f73f9eb34e7e"/>
-    <p:sldId xmlns:r="http://schemas.openxmlformats.org/officeDocument/2006/relationships" id="261" r:id="R94715ced503d47bb"/>
-    <p:sldId xmlns:r="http://schemas.openxmlformats.org/officeDocument/2006/relationships" id="262" r:id="Rdae499159fc6458b"/>
-    <p:sldId xmlns:r="http://schemas.openxmlformats.org/officeDocument/2006/relationships" id="263" r:id="R2ded5fd3a45e49e8"/>
+    <p:sldId xmlns:r="http://schemas.openxmlformats.org/officeDocument/2006/relationships" id="256" r:id="R03ce95f841bd4dff"/>
+    <p:sldId xmlns:r="http://schemas.openxmlformats.org/officeDocument/2006/relationships" id="257" r:id="R4d18fcdb802b4ea0"/>
+    <p:sldId xmlns:r="http://schemas.openxmlformats.org/officeDocument/2006/relationships" id="258" r:id="R931c2f7aea3842b2"/>
+    <p:sldId xmlns:r="http://schemas.openxmlformats.org/officeDocument/2006/relationships" id="259" r:id="Rad66ffc59b7847cf"/>
+    <p:sldId xmlns:r="http://schemas.openxmlformats.org/officeDocument/2006/relationships" id="260" r:id="R0f02de38379b4e96"/>
+    <p:sldId xmlns:r="http://schemas.openxmlformats.org/officeDocument/2006/relationships" id="261" r:id="R2727bba26ba4473a"/>
+    <p:sldId xmlns:r="http://schemas.openxmlformats.org/officeDocument/2006/relationships" id="262" r:id="Rf9afdaed92054ffc"/>
+    <p:sldId xmlns:r="http://schemas.openxmlformats.org/officeDocument/2006/relationships" id="263" r:id="Rf6cc1605bd57495c"/>
   </p:sldIdLst>
   <p:sldSz cx="12192000" cy="6858000"/>
   <p:notesSz cx="6858000" cy="9144000"/>
@@ -739,7 +739,7 @@
           <a:lstStyle xmlns:a="http://schemas.openxmlformats.org/drawingml/2006/main"/>
           <a:p xmlns:a="http://schemas.openxmlformats.org/drawingml/2006/main">
             <a:r>
-              <a:t>Explain that the browser verifies the versioned contract before any credit action. A buyer request is pending until the merchant signs openDebt.</a:t>
+              <a:t>Show the verified VPorkPay v1.1 deployment, then explain that the browser re-checks the versioned contract before any credit action. A buyer request is pending until the merchant signs openDebt.</a:t>
             </a:r>
           </a:p>
           <a:p xmlns:a="http://schemas.openxmlformats.org/drawingml/2006/main">
@@ -750,6 +750,16 @@
           <a:p xmlns:a="http://schemas.openxmlformats.org/drawingml/2006/main">
             <a:r>
               <a:t>[Sources]</a:t>
+            </a:r>
+          </a:p>
+          <a:p xmlns:a="http://schemas.openxmlformats.org/drawingml/2006/main">
+            <a:r>
+              <a:t>- https://testnet.arcscan.app/tx/0x07acbc8ad1f7a2a2ef0dddafd457b93de30a08d4dc33d6881452cc16049a0067</a:t>
+            </a:r>
+          </a:p>
+          <a:p xmlns:a="http://schemas.openxmlformats.org/drawingml/2006/main">
+            <a:r>
+              <a:t>- https://testnet.arcscan.app/address/0xd9dab755431664ada2d13868674ddb43ffdef396</a:t>
             </a:r>
           </a:p>
           <a:p xmlns:a="http://schemas.openxmlformats.org/drawingml/2006/main">
@@ -1242,7 +1252,7 @@
   </p:cSld>
   <p:clrMap bg1="lt1" tx1="dk1" bg2="lt2" tx2="dk2" accent1="accent1" accent2="accent2" accent3="accent3" accent4="accent4" accent5="accent5" accent6="accent6" hlink="hlink" folHlink="folHlink"/>
   <p:sldLayoutIdLst>
-    <p:sldLayoutId xmlns:r="http://schemas.openxmlformats.org/officeDocument/2006/relationships" id="2147483649" r:id="R522d9018b66649da"/>
+    <p:sldLayoutId xmlns:r="http://schemas.openxmlformats.org/officeDocument/2006/relationships" id="2147483649" r:id="R2c746d40b02b476d"/>
   </p:sldLayoutIdLst>
   <p:txStyles>
     <p:titleStyle>
@@ -1828,7 +1838,7 @@
           <p:nvPr/>
         </p:nvPicPr>
         <p:blipFill>
-          <a:blip xmlns:r="http://schemas.openxmlformats.org/officeDocument/2006/relationships" xmlns:a="http://schemas.openxmlformats.org/drawingml/2006/main" r:embed="R3244e25a64324de4"/>
+          <a:blip xmlns:r="http://schemas.openxmlformats.org/officeDocument/2006/relationships" xmlns:a="http://schemas.openxmlformats.org/drawingml/2006/main" r:embed="R9bb4a85ef52a4117"/>
           <a:srcRect xmlns:a="http://schemas.openxmlformats.org/drawingml/2006/main" l="90" t="0" r="90" b="0"/>
           <a:stretch xmlns:a="http://schemas.openxmlformats.org/drawingml/2006/main">
             <a:fillRect l="0" t="0" r="0" b="0"/>
@@ -1855,7 +1865,7 @@
           <p:nvPr/>
         </p:nvPicPr>
         <p:blipFill>
-          <a:blip xmlns:r="http://schemas.openxmlformats.org/officeDocument/2006/relationships" xmlns:a="http://schemas.openxmlformats.org/drawingml/2006/main" r:embed="R06a926b3b1e84208"/>
+          <a:blip xmlns:r="http://schemas.openxmlformats.org/officeDocument/2006/relationships" xmlns:a="http://schemas.openxmlformats.org/drawingml/2006/main" r:embed="R1f92ca850c284545"/>
           <a:srcRect xmlns:a="http://schemas.openxmlformats.org/drawingml/2006/main" l="0" t="10317" r="0" b="10317"/>
           <a:stretch xmlns:a="http://schemas.openxmlformats.org/drawingml/2006/main">
             <a:fillRect l="0" t="0" r="0" b="0"/>
@@ -2839,7 +2849,7 @@
           <p:nvPr/>
         </p:nvPicPr>
         <p:blipFill>
-          <a:blip xmlns:r="http://schemas.openxmlformats.org/officeDocument/2006/relationships" xmlns:a="http://schemas.openxmlformats.org/drawingml/2006/main" r:embed="R46864cf4b6554dfd"/>
+          <a:blip xmlns:r="http://schemas.openxmlformats.org/officeDocument/2006/relationships" xmlns:a="http://schemas.openxmlformats.org/drawingml/2006/main" r:embed="R15a67b731d3f401d"/>
           <a:srcRect xmlns:a="http://schemas.openxmlformats.org/drawingml/2006/main" l="25000" t="0" r="25000" b="0"/>
           <a:stretch xmlns:a="http://schemas.openxmlformats.org/drawingml/2006/main">
             <a:fillRect l="0" t="0" r="0" b="0"/>
@@ -2866,7 +2876,7 @@
           <p:nvPr/>
         </p:nvPicPr>
         <p:blipFill>
-          <a:blip xmlns:r="http://schemas.openxmlformats.org/officeDocument/2006/relationships" xmlns:a="http://schemas.openxmlformats.org/drawingml/2006/main" r:embed="R3a4bcb9f52754ab1"/>
+          <a:blip xmlns:r="http://schemas.openxmlformats.org/officeDocument/2006/relationships" xmlns:a="http://schemas.openxmlformats.org/drawingml/2006/main" r:embed="R360266254add4d97"/>
           <a:srcRect xmlns:a="http://schemas.openxmlformats.org/drawingml/2006/main" l="20682" t="0" r="20682" b="0"/>
           <a:stretch xmlns:a="http://schemas.openxmlformats.org/drawingml/2006/main">
             <a:fillRect l="0" t="0" r="0" b="0"/>
@@ -3251,7 +3261,7 @@
           <p:nvPr/>
         </p:nvPicPr>
         <p:blipFill>
-          <a:blip xmlns:r="http://schemas.openxmlformats.org/officeDocument/2006/relationships" xmlns:a="http://schemas.openxmlformats.org/drawingml/2006/main" r:embed="R152b62580db74fd8"/>
+          <a:blip xmlns:r="http://schemas.openxmlformats.org/officeDocument/2006/relationships" xmlns:a="http://schemas.openxmlformats.org/drawingml/2006/main" r:embed="Rf0ace212c2804665"/>
           <a:srcRect xmlns:a="http://schemas.openxmlformats.org/drawingml/2006/main" l="9628" t="0" r="9628" b="0"/>
           <a:stretch xmlns:a="http://schemas.openxmlformats.org/drawingml/2006/main">
             <a:fillRect l="0" t="0" r="0" b="0"/>
@@ -4049,7 +4059,7 @@
                   <a:srgbClr val="DCEB7B"/>
                 </a:solidFill>
               </a:rPr>
-              <a:t>FUNCTIONAL MVP</a:t>
+              <a:t>DEPLOYED MVP</a:t>
             </a:r>
           </a:p>
         </p:txBody>
@@ -4100,7 +4110,7 @@
                   <a:srgbClr val="FFFFFF"/>
                 </a:solidFill>
               </a:rPr>
-              <a:t>The browser verifies and operates the credit contract.</a:t>
+              <a:t>VPorkPay v1.1 is live on Arc Testnet.</a:t>
             </a:r>
           </a:p>
         </p:txBody>
@@ -4155,7 +4165,7 @@
           <p:nvPr/>
         </p:nvPicPr>
         <p:blipFill>
-          <a:blip xmlns:r="http://schemas.openxmlformats.org/officeDocument/2006/relationships" xmlns:a="http://schemas.openxmlformats.org/drawingml/2006/main" r:embed="R9d766b9dc05d424e"/>
+          <a:blip xmlns:r="http://schemas.openxmlformats.org/officeDocument/2006/relationships" xmlns:a="http://schemas.openxmlformats.org/drawingml/2006/main" r:embed="R1d0d3e237e864161"/>
           <a:srcRect xmlns:a="http://schemas.openxmlformats.org/drawingml/2006/main" l="0" t="2357" r="0" b="2357"/>
           <a:stretch xmlns:a="http://schemas.openxmlformats.org/drawingml/2006/main">
             <a:fillRect l="0" t="0" r="0" b="0"/>
@@ -4301,7 +4311,7 @@
                   <a:srgbClr val="FFFFFF"/>
                 </a:solidFill>
               </a:rPr>
-              <a:t>Verify before trust</a:t>
+              <a:t>Verified deployment</a:t>
             </a:r>
           </a:p>
         </p:txBody>
@@ -4351,8 +4361,9 @@
                 <a:solidFill>
                   <a:srgbClr val="C8CBC3"/>
                 </a:solidFill>
-              </a:rPr>
-              <a:t>Check contract ID, merchant and official Arc Testnet USDC.</a:t>
+                <a:hlinkClick xmlns:r="http://schemas.openxmlformats.org/officeDocument/2006/relationships" r:id="Rb1851e18290f4aa0"/>
+              </a:rPr>
+              <a:t>0xd9da…f396 · merchant 0xf2d0…33d0</a:t>
             </a:r>
           </a:p>
         </p:txBody>
@@ -8522,7 +8533,7 @@
           <p:nvPr/>
         </p:nvPicPr>
         <p:blipFill>
-          <a:blip xmlns:r="http://schemas.openxmlformats.org/officeDocument/2006/relationships" xmlns:a="http://schemas.openxmlformats.org/drawingml/2006/main" r:embed="Re00dea17d15540b5"/>
+          <a:blip xmlns:r="http://schemas.openxmlformats.org/officeDocument/2006/relationships" xmlns:a="http://schemas.openxmlformats.org/drawingml/2006/main" r:embed="Ra2fc749c7f414f1c"/>
           <a:srcRect xmlns:a="http://schemas.openxmlformats.org/drawingml/2006/main" l="0" t="27273" r="0" b="27273"/>
           <a:stretch xmlns:a="http://schemas.openxmlformats.org/drawingml/2006/main">
             <a:fillRect l="0" t="0" r="0" b="0"/>
@@ -8815,7 +8826,7 @@
           <p:nvPr/>
         </p:nvPicPr>
         <p:blipFill>
-          <a:blip xmlns:r="http://schemas.openxmlformats.org/officeDocument/2006/relationships" xmlns:a="http://schemas.openxmlformats.org/drawingml/2006/main" r:embed="Rc4e58b994a6746f7"/>
+          <a:blip xmlns:r="http://schemas.openxmlformats.org/officeDocument/2006/relationships" xmlns:a="http://schemas.openxmlformats.org/drawingml/2006/main" r:embed="R4949a60121d548fa"/>
           <a:srcRect xmlns:a="http://schemas.openxmlformats.org/drawingml/2006/main" l="23437" t="0" r="23437" b="0"/>
           <a:stretch xmlns:a="http://schemas.openxmlformats.org/drawingml/2006/main">
             <a:fillRect l="0" t="0" r="0" b="0"/>
@@ -9160,7 +9171,7 @@
                 <a:solidFill>
                   <a:srgbClr val="FFFFFF"/>
                 </a:solidFill>
-                <a:hlinkClick xmlns:r="http://schemas.openxmlformats.org/officeDocument/2006/relationships" r:id="R3b774a2f311a4180"/>
+                <a:hlinkClick xmlns:r="http://schemas.openxmlformats.org/officeDocument/2006/relationships" r:id="Rd3b9f93c488e4481"/>
               </a:rPr>
               <a:t>Public GitHub repository</a:t>
             </a:r>
@@ -9263,7 +9274,7 @@
                 <a:solidFill>
                   <a:srgbClr val="FFFFFF"/>
                 </a:solidFill>
-                <a:hlinkClick xmlns:r="http://schemas.openxmlformats.org/officeDocument/2006/relationships" r:id="R268a18a060b64286"/>
+                <a:hlinkClick xmlns:r="http://schemas.openxmlformats.org/officeDocument/2006/relationships" r:id="R71b5b6410c794744"/>
               </a:rPr>
               <a:t>Functional GitHub Pages MVP</a:t>
             </a:r>
@@ -9366,7 +9377,7 @@
                 <a:solidFill>
                   <a:srgbClr val="FFFFFF"/>
                 </a:solidFill>
-                <a:hlinkClick xmlns:r="http://schemas.openxmlformats.org/officeDocument/2006/relationships" r:id="R4772acaa18c44c7c"/>
+                <a:hlinkClick xmlns:r="http://schemas.openxmlformats.org/officeDocument/2006/relationships" r:id="R9336ba664dad423a"/>
               </a:rPr>
               <a:t>3-minute pitch and demo</a:t>
             </a:r>

</xml_diff>

<commit_message>
Synchronize Checkpoint 3 submission artifacts
</commit_message>
<xml_diff>
--- a/VPorkPay-Final-Submission-Deck.pptx
+++ b/VPorkPay-Final-Submission-Deck.pptx
@@ -2,20 +2,20 @@
 <file path=ppt/presentation.xml><?xml version="1.0" encoding="utf-8"?>
 <p:presentation xmlns:p="http://schemas.openxmlformats.org/presentationml/2006/main">
   <p:sldMasterIdLst>
-    <p:sldMasterId xmlns:r="http://schemas.openxmlformats.org/officeDocument/2006/relationships" id="2147483648" r:id="R35174b5681a44f44"/>
+    <p:sldMasterId xmlns:r="http://schemas.openxmlformats.org/officeDocument/2006/relationships" id="2147483648" r:id="Re1252604c0be467e"/>
   </p:sldMasterIdLst>
   <p:notesMasterIdLst>
-    <p:notesMasterId xmlns:r="http://schemas.openxmlformats.org/officeDocument/2006/relationships" r:id="Rbf2e04e6e39d44cb"/>
+    <p:notesMasterId xmlns:r="http://schemas.openxmlformats.org/officeDocument/2006/relationships" r:id="Re8675f15d2c54ef2"/>
   </p:notesMasterIdLst>
   <p:sldIdLst>
-    <p:sldId xmlns:r="http://schemas.openxmlformats.org/officeDocument/2006/relationships" id="256" r:id="Rf1daf05bd16844f2"/>
-    <p:sldId xmlns:r="http://schemas.openxmlformats.org/officeDocument/2006/relationships" id="257" r:id="Rfc9864d693a2466c"/>
-    <p:sldId xmlns:r="http://schemas.openxmlformats.org/officeDocument/2006/relationships" id="258" r:id="R7fc8689538584432"/>
-    <p:sldId xmlns:r="http://schemas.openxmlformats.org/officeDocument/2006/relationships" id="259" r:id="Rca00872ff4974375"/>
-    <p:sldId xmlns:r="http://schemas.openxmlformats.org/officeDocument/2006/relationships" id="260" r:id="R98c52f9339804fa0"/>
-    <p:sldId xmlns:r="http://schemas.openxmlformats.org/officeDocument/2006/relationships" id="261" r:id="R225cb0d8f3b54d7a"/>
-    <p:sldId xmlns:r="http://schemas.openxmlformats.org/officeDocument/2006/relationships" id="262" r:id="R8d939444bbef4b1e"/>
-    <p:sldId xmlns:r="http://schemas.openxmlformats.org/officeDocument/2006/relationships" id="263" r:id="R664c9edf47fb4329"/>
+    <p:sldId xmlns:r="http://schemas.openxmlformats.org/officeDocument/2006/relationships" id="256" r:id="Rcc366724a74b4914"/>
+    <p:sldId xmlns:r="http://schemas.openxmlformats.org/officeDocument/2006/relationships" id="257" r:id="Rf31efbe45d8d4d41"/>
+    <p:sldId xmlns:r="http://schemas.openxmlformats.org/officeDocument/2006/relationships" id="258" r:id="Rc160c1518b504a82"/>
+    <p:sldId xmlns:r="http://schemas.openxmlformats.org/officeDocument/2006/relationships" id="259" r:id="Rb5c47a7c0eec4be3"/>
+    <p:sldId xmlns:r="http://schemas.openxmlformats.org/officeDocument/2006/relationships" id="260" r:id="Rdaeb05f8aad84184"/>
+    <p:sldId xmlns:r="http://schemas.openxmlformats.org/officeDocument/2006/relationships" id="261" r:id="Rcd49f35bf6224ab8"/>
+    <p:sldId xmlns:r="http://schemas.openxmlformats.org/officeDocument/2006/relationships" id="262" r:id="R65b74d10e9e74237"/>
+    <p:sldId xmlns:r="http://schemas.openxmlformats.org/officeDocument/2006/relationships" id="263" r:id="R7e3300b5cb634516"/>
   </p:sldIdLst>
   <p:sldSz cx="12192000" cy="6858000"/>
   <p:notesSz cx="6858000" cy="9144000"/>
@@ -1287,7 +1287,7 @@
   </p:cSld>
   <p:clrMap bg1="lt1" tx1="dk1" bg2="lt2" tx2="dk2" accent1="accent1" accent2="accent2" accent3="accent3" accent4="accent4" accent5="accent5" accent6="accent6" hlink="hlink" folHlink="folHlink"/>
   <p:sldLayoutIdLst>
-    <p:sldLayoutId xmlns:r="http://schemas.openxmlformats.org/officeDocument/2006/relationships" id="2147483649" r:id="Rae6a050afd374ab6"/>
+    <p:sldLayoutId xmlns:r="http://schemas.openxmlformats.org/officeDocument/2006/relationships" id="2147483649" r:id="R55de36e699a44c85"/>
   </p:sldLayoutIdLst>
   <p:txStyles>
     <p:titleStyle>
@@ -1961,6 +1961,7 @@
           <a:lstStyle xmlns:a="http://schemas.openxmlformats.org/drawingml/2006/main"/>
           <a:p xmlns:a="http://schemas.openxmlformats.org/drawingml/2006/main">
             <a:pPr algn="ctr">
+              <a:buNone/>
               <a:defRPr sz="900" b="1" i="0">
                 <a:solidFill>
                   <a:srgbClr val="FFFDF8"/>
@@ -2019,6 +2020,7 @@
           <a:lstStyle xmlns:a="http://schemas.openxmlformats.org/drawingml/2006/main"/>
           <a:p xmlns:a="http://schemas.openxmlformats.org/drawingml/2006/main">
             <a:pPr algn="l">
+              <a:buNone/>
               <a:defRPr sz="825" b="1" i="0">
                 <a:solidFill>
                   <a:srgbClr val="0C665A"/>
@@ -2077,6 +2079,7 @@
           <a:lstStyle xmlns:a="http://schemas.openxmlformats.org/drawingml/2006/main"/>
           <a:p xmlns:a="http://schemas.openxmlformats.org/drawingml/2006/main">
             <a:pPr algn="l">
+              <a:buNone/>
               <a:defRPr sz="4350" b="1" i="0">
                 <a:solidFill>
                   <a:srgbClr val="17211D"/>
@@ -2135,6 +2138,7 @@
           <a:lstStyle xmlns:a="http://schemas.openxmlformats.org/drawingml/2006/main"/>
           <a:p xmlns:a="http://schemas.openxmlformats.org/drawingml/2006/main">
             <a:pPr algn="l">
+              <a:buNone/>
               <a:defRPr sz="4200" b="1" i="0">
                 <a:solidFill>
                   <a:srgbClr val="D94B32"/>
@@ -2158,6 +2162,7 @@
           </a:p>
           <a:p xmlns:a="http://schemas.openxmlformats.org/drawingml/2006/main">
             <a:pPr algn="l">
+              <a:buNone/>
               <a:defRPr sz="4200" b="1" i="0">
                 <a:solidFill>
                   <a:srgbClr val="D94B32"/>
@@ -2216,6 +2221,7 @@
           <a:lstStyle xmlns:a="http://schemas.openxmlformats.org/drawingml/2006/main"/>
           <a:p xmlns:a="http://schemas.openxmlformats.org/drawingml/2006/main">
             <a:pPr algn="l">
+              <a:buNone/>
               <a:defRPr sz="1425" b="0" i="0">
                 <a:solidFill>
                   <a:srgbClr val="6F746E"/>
@@ -2307,6 +2313,7 @@
           <a:lstStyle xmlns:a="http://schemas.openxmlformats.org/drawingml/2006/main"/>
           <a:p xmlns:a="http://schemas.openxmlformats.org/drawingml/2006/main">
             <a:pPr algn="ctr">
+              <a:buNone/>
               <a:defRPr sz="825" b="1" i="0">
                 <a:solidFill>
                   <a:srgbClr val="FFFDF8"/>
@@ -2332,14 +2339,14 @@
       </p:sp>
       <p:pic>
         <p:nvPicPr>
-          <p:cNvPr id="22" name=""/>
+          <p:cNvPr id="24" name=""/>
           <p:cNvPicPr>
             <a:picLocks xmlns:a="http://schemas.openxmlformats.org/drawingml/2006/main" noChangeAspect="1"/>
           </p:cNvPicPr>
           <p:nvPr/>
         </p:nvPicPr>
         <p:blipFill>
-          <a:blip xmlns:r="http://schemas.openxmlformats.org/officeDocument/2006/relationships" xmlns:a="http://schemas.openxmlformats.org/drawingml/2006/main" r:embed="R2d131f458b8741b3"/>
+          <a:blip xmlns:r="http://schemas.openxmlformats.org/officeDocument/2006/relationships" xmlns:a="http://schemas.openxmlformats.org/drawingml/2006/main" r:embed="R7c97853038074d9d"/>
           <a:srcRect xmlns:a="http://schemas.openxmlformats.org/drawingml/2006/main" l="21455" t="0" r="21455" b="0"/>
           <a:stretch xmlns:a="http://schemas.openxmlformats.org/drawingml/2006/main">
             <a:fillRect l="0" t="0" r="0" b="0"/>
@@ -2351,9 +2358,7 @@
             <a:ext cx="3886200" cy="5105400"/>
           </a:xfrm>
           <a:prstGeom xmlns:a="http://schemas.openxmlformats.org/drawingml/2006/main" prst="roundRect">
-            <a:avLst>
-              <a:gd name="adj" fmla="val 2941"/>
-            </a:avLst>
+            <a:avLst/>
           </a:prstGeom>
         </p:spPr>
       </p:pic>
@@ -2452,6 +2457,7 @@
           <a:lstStyle xmlns:a="http://schemas.openxmlformats.org/drawingml/2006/main"/>
           <a:p xmlns:a="http://schemas.openxmlformats.org/drawingml/2006/main">
             <a:pPr algn="ctr">
+              <a:buNone/>
               <a:defRPr sz="675" b="1" i="0">
                 <a:solidFill>
                   <a:srgbClr val="FFFDF8"/>
@@ -2510,6 +2516,7 @@
           <a:lstStyle xmlns:a="http://schemas.openxmlformats.org/drawingml/2006/main"/>
           <a:p xmlns:a="http://schemas.openxmlformats.org/drawingml/2006/main">
             <a:pPr algn="l">
+              <a:buNone/>
               <a:defRPr sz="1200" b="1" i="0">
                 <a:solidFill>
                   <a:srgbClr val="17211D"/>
@@ -2568,6 +2575,7 @@
           <a:lstStyle xmlns:a="http://schemas.openxmlformats.org/drawingml/2006/main"/>
           <a:p xmlns:a="http://schemas.openxmlformats.org/drawingml/2006/main">
             <a:pPr algn="r">
+              <a:buNone/>
               <a:defRPr sz="900" b="1" i="0">
                 <a:solidFill>
                   <a:srgbClr val="6F746E"/>
@@ -2626,6 +2634,7 @@
           <a:lstStyle xmlns:a="http://schemas.openxmlformats.org/drawingml/2006/main"/>
           <a:p xmlns:a="http://schemas.openxmlformats.org/drawingml/2006/main">
             <a:pPr algn="l">
+              <a:buNone/>
               <a:defRPr sz="825" b="1" i="0">
                 <a:solidFill>
                   <a:srgbClr val="D94B32"/>
@@ -2684,6 +2693,7 @@
           <a:lstStyle xmlns:a="http://schemas.openxmlformats.org/drawingml/2006/main"/>
           <a:p xmlns:a="http://schemas.openxmlformats.org/drawingml/2006/main">
             <a:pPr algn="l">
+              <a:buNone/>
               <a:defRPr sz="3450" b="1" i="0">
                 <a:solidFill>
                   <a:srgbClr val="17211D"/>
@@ -2742,6 +2752,7 @@
           <a:lstStyle xmlns:a="http://schemas.openxmlformats.org/drawingml/2006/main"/>
           <a:p xmlns:a="http://schemas.openxmlformats.org/drawingml/2006/main">
             <a:pPr algn="l">
+              <a:buNone/>
               <a:defRPr sz="975" b="1" i="0">
                 <a:solidFill>
                   <a:srgbClr val="D94B32"/>
@@ -2800,6 +2811,7 @@
           <a:lstStyle xmlns:a="http://schemas.openxmlformats.org/drawingml/2006/main"/>
           <a:p xmlns:a="http://schemas.openxmlformats.org/drawingml/2006/main">
             <a:pPr algn="l">
+              <a:buNone/>
               <a:defRPr sz="1425" b="1" i="0">
                 <a:solidFill>
                   <a:srgbClr val="17211D"/>
@@ -2858,6 +2870,7 @@
           <a:lstStyle xmlns:a="http://schemas.openxmlformats.org/drawingml/2006/main"/>
           <a:p xmlns:a="http://schemas.openxmlformats.org/drawingml/2006/main">
             <a:pPr algn="l">
+              <a:buNone/>
               <a:defRPr sz="1050" b="0" i="0">
                 <a:solidFill>
                   <a:srgbClr val="6F746E"/>
@@ -2947,6 +2960,7 @@
           <a:lstStyle xmlns:a="http://schemas.openxmlformats.org/drawingml/2006/main"/>
           <a:p xmlns:a="http://schemas.openxmlformats.org/drawingml/2006/main">
             <a:pPr algn="l">
+              <a:buNone/>
               <a:defRPr sz="975" b="1" i="0">
                 <a:solidFill>
                   <a:srgbClr val="D94B32"/>
@@ -3005,6 +3019,7 @@
           <a:lstStyle xmlns:a="http://schemas.openxmlformats.org/drawingml/2006/main"/>
           <a:p xmlns:a="http://schemas.openxmlformats.org/drawingml/2006/main">
             <a:pPr algn="l">
+              <a:buNone/>
               <a:defRPr sz="1425" b="1" i="0">
                 <a:solidFill>
                   <a:srgbClr val="17211D"/>
@@ -3063,6 +3078,7 @@
           <a:lstStyle xmlns:a="http://schemas.openxmlformats.org/drawingml/2006/main"/>
           <a:p xmlns:a="http://schemas.openxmlformats.org/drawingml/2006/main">
             <a:pPr algn="l">
+              <a:buNone/>
               <a:defRPr sz="1050" b="0" i="0">
                 <a:solidFill>
                   <a:srgbClr val="6F746E"/>
@@ -3152,6 +3168,7 @@
           <a:lstStyle xmlns:a="http://schemas.openxmlformats.org/drawingml/2006/main"/>
           <a:p xmlns:a="http://schemas.openxmlformats.org/drawingml/2006/main">
             <a:pPr algn="l">
+              <a:buNone/>
               <a:defRPr sz="975" b="1" i="0">
                 <a:solidFill>
                   <a:srgbClr val="D94B32"/>
@@ -3210,6 +3227,7 @@
           <a:lstStyle xmlns:a="http://schemas.openxmlformats.org/drawingml/2006/main"/>
           <a:p xmlns:a="http://schemas.openxmlformats.org/drawingml/2006/main">
             <a:pPr algn="l">
+              <a:buNone/>
               <a:defRPr sz="1425" b="1" i="0">
                 <a:solidFill>
                   <a:srgbClr val="17211D"/>
@@ -3268,6 +3286,7 @@
           <a:lstStyle xmlns:a="http://schemas.openxmlformats.org/drawingml/2006/main"/>
           <a:p xmlns:a="http://schemas.openxmlformats.org/drawingml/2006/main">
             <a:pPr algn="l">
+              <a:buNone/>
               <a:defRPr sz="1050" b="0" i="0">
                 <a:solidFill>
                   <a:srgbClr val="6F746E"/>
@@ -3359,6 +3378,7 @@
           <a:lstStyle xmlns:a="http://schemas.openxmlformats.org/drawingml/2006/main"/>
           <a:p xmlns:a="http://schemas.openxmlformats.org/drawingml/2006/main">
             <a:pPr algn="l">
+              <a:buNone/>
               <a:defRPr sz="2100" b="1" i="0">
                 <a:solidFill>
                   <a:srgbClr val="FFFDF8"/>
@@ -3382,6 +3402,7 @@
           </a:p>
           <a:p xmlns:a="http://schemas.openxmlformats.org/drawingml/2006/main">
             <a:pPr algn="l">
+              <a:buNone/>
               <a:defRPr sz="2100" b="1" i="0">
                 <a:solidFill>
                   <a:srgbClr val="FFFDF8"/>
@@ -3405,6 +3426,7 @@
           </a:p>
           <a:p xmlns:a="http://schemas.openxmlformats.org/drawingml/2006/main">
             <a:pPr algn="l">
+              <a:buNone/>
               <a:defRPr sz="2100" b="1" i="0">
                 <a:solidFill>
                   <a:srgbClr val="FFFDF8"/>
@@ -3463,6 +3485,7 @@
           <a:lstStyle xmlns:a="http://schemas.openxmlformats.org/drawingml/2006/main"/>
           <a:p xmlns:a="http://schemas.openxmlformats.org/drawingml/2006/main">
             <a:pPr algn="l">
+              <a:buNone/>
               <a:defRPr sz="1050" b="0" i="0">
                 <a:solidFill>
                   <a:srgbClr val="FFECE6"/>
@@ -3521,6 +3544,7 @@
           <a:lstStyle xmlns:a="http://schemas.openxmlformats.org/drawingml/2006/main"/>
           <a:p xmlns:a="http://schemas.openxmlformats.org/drawingml/2006/main">
             <a:pPr algn="l">
+              <a:buNone/>
               <a:defRPr sz="675" b="1" i="0">
                 <a:solidFill>
                   <a:srgbClr val="6F746E"/>
@@ -3579,6 +3603,7 @@
           <a:lstStyle xmlns:a="http://schemas.openxmlformats.org/drawingml/2006/main"/>
           <a:p xmlns:a="http://schemas.openxmlformats.org/drawingml/2006/main">
             <a:pPr algn="r">
+              <a:buNone/>
               <a:defRPr sz="675" b="1" i="0">
                 <a:solidFill>
                   <a:srgbClr val="6F746E"/>
@@ -3697,6 +3722,7 @@
           <a:lstStyle xmlns:a="http://schemas.openxmlformats.org/drawingml/2006/main"/>
           <a:p xmlns:a="http://schemas.openxmlformats.org/drawingml/2006/main">
             <a:pPr algn="ctr">
+              <a:buNone/>
               <a:defRPr sz="675" b="1" i="0">
                 <a:solidFill>
                   <a:srgbClr val="FFFDF8"/>
@@ -3755,6 +3781,7 @@
           <a:lstStyle xmlns:a="http://schemas.openxmlformats.org/drawingml/2006/main"/>
           <a:p xmlns:a="http://schemas.openxmlformats.org/drawingml/2006/main">
             <a:pPr algn="l">
+              <a:buNone/>
               <a:defRPr sz="1200" b="1" i="0">
                 <a:solidFill>
                   <a:srgbClr val="17211D"/>
@@ -3813,6 +3840,7 @@
           <a:lstStyle xmlns:a="http://schemas.openxmlformats.org/drawingml/2006/main"/>
           <a:p xmlns:a="http://schemas.openxmlformats.org/drawingml/2006/main">
             <a:pPr algn="r">
+              <a:buNone/>
               <a:defRPr sz="900" b="1" i="0">
                 <a:solidFill>
                   <a:srgbClr val="6F746E"/>
@@ -3871,6 +3899,7 @@
           <a:lstStyle xmlns:a="http://schemas.openxmlformats.org/drawingml/2006/main"/>
           <a:p xmlns:a="http://schemas.openxmlformats.org/drawingml/2006/main">
             <a:pPr algn="l">
+              <a:buNone/>
               <a:defRPr sz="825" b="1" i="0">
                 <a:solidFill>
                   <a:srgbClr val="D94B32"/>
@@ -3929,6 +3958,7 @@
           <a:lstStyle xmlns:a="http://schemas.openxmlformats.org/drawingml/2006/main"/>
           <a:p xmlns:a="http://schemas.openxmlformats.org/drawingml/2006/main">
             <a:pPr algn="l">
+              <a:buNone/>
               <a:defRPr sz="3450" b="1" i="0">
                 <a:solidFill>
                   <a:srgbClr val="17211D"/>
@@ -4055,6 +4085,7 @@
           <a:lstStyle xmlns:a="http://schemas.openxmlformats.org/drawingml/2006/main"/>
           <a:p xmlns:a="http://schemas.openxmlformats.org/drawingml/2006/main">
             <a:pPr algn="ctr">
+              <a:buNone/>
               <a:defRPr sz="825" b="1" i="0">
                 <a:solidFill>
                   <a:srgbClr val="FFFDF8"/>
@@ -4113,6 +4144,7 @@
           <a:lstStyle xmlns:a="http://schemas.openxmlformats.org/drawingml/2006/main"/>
           <a:p xmlns:a="http://schemas.openxmlformats.org/drawingml/2006/main">
             <a:pPr algn="l">
+              <a:buNone/>
               <a:defRPr sz="1500" b="1" i="0">
                 <a:solidFill>
                   <a:srgbClr val="17211D"/>
@@ -4171,6 +4203,7 @@
           <a:lstStyle xmlns:a="http://schemas.openxmlformats.org/drawingml/2006/main"/>
           <a:p xmlns:a="http://schemas.openxmlformats.org/drawingml/2006/main">
             <a:pPr algn="l">
+              <a:buNone/>
               <a:defRPr sz="900" b="0" i="0">
                 <a:solidFill>
                   <a:srgbClr val="6F746E"/>
@@ -4297,6 +4330,7 @@
           <a:lstStyle xmlns:a="http://schemas.openxmlformats.org/drawingml/2006/main"/>
           <a:p xmlns:a="http://schemas.openxmlformats.org/drawingml/2006/main">
             <a:pPr algn="ctr">
+              <a:buNone/>
               <a:defRPr sz="825" b="1" i="0">
                 <a:solidFill>
                   <a:srgbClr val="FFFDF8"/>
@@ -4355,6 +4389,7 @@
           <a:lstStyle xmlns:a="http://schemas.openxmlformats.org/drawingml/2006/main"/>
           <a:p xmlns:a="http://schemas.openxmlformats.org/drawingml/2006/main">
             <a:pPr algn="l">
+              <a:buNone/>
               <a:defRPr sz="1500" b="1" i="0">
                 <a:solidFill>
                   <a:srgbClr val="17211D"/>
@@ -4413,6 +4448,7 @@
           <a:lstStyle xmlns:a="http://schemas.openxmlformats.org/drawingml/2006/main"/>
           <a:p xmlns:a="http://schemas.openxmlformats.org/drawingml/2006/main">
             <a:pPr algn="l">
+              <a:buNone/>
               <a:defRPr sz="900" b="0" i="0">
                 <a:solidFill>
                   <a:srgbClr val="6F746E"/>
@@ -4539,6 +4575,7 @@
           <a:lstStyle xmlns:a="http://schemas.openxmlformats.org/drawingml/2006/main"/>
           <a:p xmlns:a="http://schemas.openxmlformats.org/drawingml/2006/main">
             <a:pPr algn="ctr">
+              <a:buNone/>
               <a:defRPr sz="825" b="1" i="0">
                 <a:solidFill>
                   <a:srgbClr val="FFFDF8"/>
@@ -4597,6 +4634,7 @@
           <a:lstStyle xmlns:a="http://schemas.openxmlformats.org/drawingml/2006/main"/>
           <a:p xmlns:a="http://schemas.openxmlformats.org/drawingml/2006/main">
             <a:pPr algn="l">
+              <a:buNone/>
               <a:defRPr sz="1500" b="1" i="0">
                 <a:solidFill>
                   <a:srgbClr val="FFFDF8"/>
@@ -4655,6 +4693,7 @@
           <a:lstStyle xmlns:a="http://schemas.openxmlformats.org/drawingml/2006/main"/>
           <a:p xmlns:a="http://schemas.openxmlformats.org/drawingml/2006/main">
             <a:pPr algn="l">
+              <a:buNone/>
               <a:defRPr sz="900" b="0" i="0">
                 <a:solidFill>
                   <a:srgbClr val="C7D0CB"/>
@@ -4777,6 +4816,7 @@
           <a:lstStyle xmlns:a="http://schemas.openxmlformats.org/drawingml/2006/main"/>
           <a:p xmlns:a="http://schemas.openxmlformats.org/drawingml/2006/main">
             <a:pPr algn="ctr">
+              <a:buNone/>
               <a:defRPr sz="1050" b="1" i="0">
                 <a:solidFill>
                   <a:srgbClr val="FFFDF8"/>
@@ -4835,6 +4875,7 @@
           <a:lstStyle xmlns:a="http://schemas.openxmlformats.org/drawingml/2006/main"/>
           <a:p xmlns:a="http://schemas.openxmlformats.org/drawingml/2006/main">
             <a:pPr algn="l">
+              <a:buNone/>
               <a:defRPr sz="750" b="1" i="0">
                 <a:solidFill>
                   <a:srgbClr val="0C665A"/>
@@ -4893,6 +4934,7 @@
           <a:lstStyle xmlns:a="http://schemas.openxmlformats.org/drawingml/2006/main"/>
           <a:p xmlns:a="http://schemas.openxmlformats.org/drawingml/2006/main">
             <a:pPr algn="l">
+              <a:buNone/>
               <a:defRPr sz="1125" b="1" i="0">
                 <a:solidFill>
                   <a:srgbClr val="17211D"/>
@@ -5015,6 +5057,7 @@
           <a:lstStyle xmlns:a="http://schemas.openxmlformats.org/drawingml/2006/main"/>
           <a:p xmlns:a="http://schemas.openxmlformats.org/drawingml/2006/main">
             <a:pPr algn="ctr">
+              <a:buNone/>
               <a:defRPr sz="1050" b="1" i="0">
                 <a:solidFill>
                   <a:srgbClr val="17211D"/>
@@ -5073,6 +5116,7 @@
           <a:lstStyle xmlns:a="http://schemas.openxmlformats.org/drawingml/2006/main"/>
           <a:p xmlns:a="http://schemas.openxmlformats.org/drawingml/2006/main">
             <a:pPr algn="l">
+              <a:buNone/>
               <a:defRPr sz="750" b="1" i="0">
                 <a:solidFill>
                   <a:srgbClr val="805B00"/>
@@ -5131,6 +5175,7 @@
           <a:lstStyle xmlns:a="http://schemas.openxmlformats.org/drawingml/2006/main"/>
           <a:p xmlns:a="http://schemas.openxmlformats.org/drawingml/2006/main">
             <a:pPr algn="l">
+              <a:buNone/>
               <a:defRPr sz="1125" b="1" i="0">
                 <a:solidFill>
                   <a:srgbClr val="17211D"/>
@@ -5189,6 +5234,7 @@
           <a:lstStyle xmlns:a="http://schemas.openxmlformats.org/drawingml/2006/main"/>
           <a:p xmlns:a="http://schemas.openxmlformats.org/drawingml/2006/main">
             <a:pPr algn="l">
+              <a:buNone/>
               <a:defRPr sz="675" b="1" i="0">
                 <a:solidFill>
                   <a:srgbClr val="6F746E"/>
@@ -5247,6 +5293,7 @@
           <a:lstStyle xmlns:a="http://schemas.openxmlformats.org/drawingml/2006/main"/>
           <a:p xmlns:a="http://schemas.openxmlformats.org/drawingml/2006/main">
             <a:pPr algn="r">
+              <a:buNone/>
               <a:defRPr sz="675" b="1" i="0">
                 <a:solidFill>
                   <a:srgbClr val="6F746E"/>
@@ -5365,6 +5412,7 @@
           <a:lstStyle xmlns:a="http://schemas.openxmlformats.org/drawingml/2006/main"/>
           <a:p xmlns:a="http://schemas.openxmlformats.org/drawingml/2006/main">
             <a:pPr algn="ctr">
+              <a:buNone/>
               <a:defRPr sz="675" b="1" i="0">
                 <a:solidFill>
                   <a:srgbClr val="FFFDF8"/>
@@ -5423,6 +5471,7 @@
           <a:lstStyle xmlns:a="http://schemas.openxmlformats.org/drawingml/2006/main"/>
           <a:p xmlns:a="http://schemas.openxmlformats.org/drawingml/2006/main">
             <a:pPr algn="l">
+              <a:buNone/>
               <a:defRPr sz="1200" b="1" i="0">
                 <a:solidFill>
                   <a:srgbClr val="FFFDF8"/>
@@ -5481,6 +5530,7 @@
           <a:lstStyle xmlns:a="http://schemas.openxmlformats.org/drawingml/2006/main"/>
           <a:p xmlns:a="http://schemas.openxmlformats.org/drawingml/2006/main">
             <a:pPr algn="r">
+              <a:buNone/>
               <a:defRPr sz="900" b="1" i="0">
                 <a:solidFill>
                   <a:srgbClr val="AAB4AE"/>
@@ -5539,6 +5589,7 @@
           <a:lstStyle xmlns:a="http://schemas.openxmlformats.org/drawingml/2006/main"/>
           <a:p xmlns:a="http://schemas.openxmlformats.org/drawingml/2006/main">
             <a:pPr algn="l">
+              <a:buNone/>
               <a:defRPr sz="825" b="1" i="0">
                 <a:solidFill>
                   <a:srgbClr val="E8B64B"/>
@@ -5597,6 +5648,7 @@
           <a:lstStyle xmlns:a="http://schemas.openxmlformats.org/drawingml/2006/main"/>
           <a:p xmlns:a="http://schemas.openxmlformats.org/drawingml/2006/main">
             <a:pPr algn="l">
+              <a:buNone/>
               <a:defRPr sz="3300" b="1" i="0">
                 <a:solidFill>
                   <a:srgbClr val="FFFDF8"/>
@@ -5690,6 +5742,7 @@
           <a:lstStyle xmlns:a="http://schemas.openxmlformats.org/drawingml/2006/main"/>
           <a:p xmlns:a="http://schemas.openxmlformats.org/drawingml/2006/main">
             <a:pPr algn="l">
+              <a:buNone/>
               <a:defRPr sz="825" b="1" i="0">
                 <a:solidFill>
                   <a:srgbClr val="E8B64B"/>
@@ -5748,6 +5801,7 @@
           <a:lstStyle xmlns:a="http://schemas.openxmlformats.org/drawingml/2006/main"/>
           <a:p xmlns:a="http://schemas.openxmlformats.org/drawingml/2006/main">
             <a:pPr algn="l">
+              <a:buNone/>
               <a:defRPr sz="2100" b="1" i="0">
                 <a:solidFill>
                   <a:srgbClr val="FFFDF8"/>
@@ -5806,6 +5860,7 @@
           <a:lstStyle xmlns:a="http://schemas.openxmlformats.org/drawingml/2006/main"/>
           <a:p xmlns:a="http://schemas.openxmlformats.org/drawingml/2006/main">
             <a:pPr algn="l">
+              <a:buNone/>
               <a:defRPr sz="1050" b="0" i="0">
                 <a:solidFill>
                   <a:srgbClr val="C7D0CB"/>
@@ -5899,6 +5954,7 @@
           <a:lstStyle xmlns:a="http://schemas.openxmlformats.org/drawingml/2006/main"/>
           <a:p xmlns:a="http://schemas.openxmlformats.org/drawingml/2006/main">
             <a:pPr algn="l">
+              <a:buNone/>
               <a:defRPr sz="825" b="1" i="0">
                 <a:solidFill>
                   <a:srgbClr val="FFEDE8"/>
@@ -5957,6 +6013,7 @@
           <a:lstStyle xmlns:a="http://schemas.openxmlformats.org/drawingml/2006/main"/>
           <a:p xmlns:a="http://schemas.openxmlformats.org/drawingml/2006/main">
             <a:pPr algn="l">
+              <a:buNone/>
               <a:defRPr sz="2100" b="1" i="0">
                 <a:solidFill>
                   <a:srgbClr val="FFFDF8"/>
@@ -6015,6 +6072,7 @@
           <a:lstStyle xmlns:a="http://schemas.openxmlformats.org/drawingml/2006/main"/>
           <a:p xmlns:a="http://schemas.openxmlformats.org/drawingml/2006/main">
             <a:pPr algn="l">
+              <a:buNone/>
               <a:defRPr sz="1050" b="0" i="0">
                 <a:solidFill>
                   <a:srgbClr val="FFEDE8"/>
@@ -6108,6 +6166,7 @@
           <a:lstStyle xmlns:a="http://schemas.openxmlformats.org/drawingml/2006/main"/>
           <a:p xmlns:a="http://schemas.openxmlformats.org/drawingml/2006/main">
             <a:pPr algn="l">
+              <a:buNone/>
               <a:defRPr sz="825" b="1" i="0">
                 <a:solidFill>
                   <a:srgbClr val="E8B64B"/>
@@ -6166,6 +6225,7 @@
           <a:lstStyle xmlns:a="http://schemas.openxmlformats.org/drawingml/2006/main"/>
           <a:p xmlns:a="http://schemas.openxmlformats.org/drawingml/2006/main">
             <a:pPr algn="l">
+              <a:buNone/>
               <a:defRPr sz="2100" b="1" i="0">
                 <a:solidFill>
                   <a:srgbClr val="FFFDF8"/>
@@ -6224,6 +6284,7 @@
           <a:lstStyle xmlns:a="http://schemas.openxmlformats.org/drawingml/2006/main"/>
           <a:p xmlns:a="http://schemas.openxmlformats.org/drawingml/2006/main">
             <a:pPr algn="l">
+              <a:buNone/>
               <a:defRPr sz="1050" b="0" i="0">
                 <a:solidFill>
                   <a:srgbClr val="C7D0CB"/>
@@ -6282,6 +6343,7 @@
           <a:lstStyle xmlns:a="http://schemas.openxmlformats.org/drawingml/2006/main"/>
           <a:p xmlns:a="http://schemas.openxmlformats.org/drawingml/2006/main">
             <a:pPr algn="l">
+              <a:buNone/>
               <a:defRPr sz="1050" b="0" i="0">
                 <a:solidFill>
                   <a:srgbClr val="FFFDF8"/>
@@ -6310,7 +6372,7 @@
                 <a:latin typeface="Avenir Next"/>
                 <a:ea typeface="Avenir Next"/>
                 <a:cs typeface="Avenir Next"/>
-                <a:hlinkClick xmlns:r="http://schemas.openxmlformats.org/officeDocument/2006/relationships" r:id="Re773a3068e334c35"/>
+                <a:hlinkClick xmlns:r="http://schemas.openxmlformats.org/officeDocument/2006/relationships" r:id="Rd3c19f905d9b4a12"/>
               </a:rPr>
               <a:t>https://vpork.xyz/</a:t>
             </a:r>
@@ -6385,6 +6447,7 @@
           <a:lstStyle xmlns:a="http://schemas.openxmlformats.org/drawingml/2006/main"/>
           <a:p xmlns:a="http://schemas.openxmlformats.org/drawingml/2006/main">
             <a:pPr algn="ctr">
+              <a:buNone/>
               <a:defRPr sz="825" b="1" i="0">
                 <a:solidFill>
                   <a:srgbClr val="FFFDF8"/>
@@ -6476,6 +6539,7 @@
           <a:lstStyle xmlns:a="http://schemas.openxmlformats.org/drawingml/2006/main"/>
           <a:p xmlns:a="http://schemas.openxmlformats.org/drawingml/2006/main">
             <a:pPr algn="ctr">
+              <a:buNone/>
               <a:defRPr sz="825" b="1" i="0">
                 <a:solidFill>
                   <a:srgbClr val="17211D"/>
@@ -6534,6 +6598,7 @@
           <a:lstStyle xmlns:a="http://schemas.openxmlformats.org/drawingml/2006/main"/>
           <a:p xmlns:a="http://schemas.openxmlformats.org/drawingml/2006/main">
             <a:pPr algn="l">
+              <a:buNone/>
               <a:defRPr sz="675" b="1" i="0">
                 <a:solidFill>
                   <a:srgbClr val="AAB4AE"/>
@@ -6592,6 +6657,7 @@
           <a:lstStyle xmlns:a="http://schemas.openxmlformats.org/drawingml/2006/main"/>
           <a:p xmlns:a="http://schemas.openxmlformats.org/drawingml/2006/main">
             <a:pPr algn="r">
+              <a:buNone/>
               <a:defRPr sz="675" b="1" i="0">
                 <a:solidFill>
                   <a:srgbClr val="AAB4AE"/>
@@ -6710,6 +6776,7 @@
           <a:lstStyle xmlns:a="http://schemas.openxmlformats.org/drawingml/2006/main"/>
           <a:p xmlns:a="http://schemas.openxmlformats.org/drawingml/2006/main">
             <a:pPr algn="ctr">
+              <a:buNone/>
               <a:defRPr sz="675" b="1" i="0">
                 <a:solidFill>
                   <a:srgbClr val="FFFDF8"/>
@@ -6768,6 +6835,7 @@
           <a:lstStyle xmlns:a="http://schemas.openxmlformats.org/drawingml/2006/main"/>
           <a:p xmlns:a="http://schemas.openxmlformats.org/drawingml/2006/main">
             <a:pPr algn="l">
+              <a:buNone/>
               <a:defRPr sz="1200" b="1" i="0">
                 <a:solidFill>
                   <a:srgbClr val="17211D"/>
@@ -6826,6 +6894,7 @@
           <a:lstStyle xmlns:a="http://schemas.openxmlformats.org/drawingml/2006/main"/>
           <a:p xmlns:a="http://schemas.openxmlformats.org/drawingml/2006/main">
             <a:pPr algn="r">
+              <a:buNone/>
               <a:defRPr sz="900" b="1" i="0">
                 <a:solidFill>
                   <a:srgbClr val="6F746E"/>
@@ -6884,6 +6953,7 @@
           <a:lstStyle xmlns:a="http://schemas.openxmlformats.org/drawingml/2006/main"/>
           <a:p xmlns:a="http://schemas.openxmlformats.org/drawingml/2006/main">
             <a:pPr algn="l">
+              <a:buNone/>
               <a:defRPr sz="825" b="1" i="0">
                 <a:solidFill>
                   <a:srgbClr val="D94B32"/>
@@ -6942,6 +7012,7 @@
           <a:lstStyle xmlns:a="http://schemas.openxmlformats.org/drawingml/2006/main"/>
           <a:p xmlns:a="http://schemas.openxmlformats.org/drawingml/2006/main">
             <a:pPr algn="l">
+              <a:buNone/>
               <a:defRPr sz="3450" b="1" i="0">
                 <a:solidFill>
                   <a:srgbClr val="17211D"/>
@@ -7035,6 +7106,7 @@
           <a:lstStyle xmlns:a="http://schemas.openxmlformats.org/drawingml/2006/main"/>
           <a:p xmlns:a="http://schemas.openxmlformats.org/drawingml/2006/main">
             <a:pPr algn="l">
+              <a:buNone/>
               <a:defRPr sz="750" b="1" i="0">
                 <a:solidFill>
                   <a:srgbClr val="6F746E"/>
@@ -7093,6 +7165,7 @@
           <a:lstStyle xmlns:a="http://schemas.openxmlformats.org/drawingml/2006/main"/>
           <a:p xmlns:a="http://schemas.openxmlformats.org/drawingml/2006/main">
             <a:pPr algn="l">
+              <a:buNone/>
               <a:defRPr sz="2250" b="1" i="0">
                 <a:solidFill>
                   <a:srgbClr val="0C665A"/>
@@ -7151,6 +7224,7 @@
           <a:lstStyle xmlns:a="http://schemas.openxmlformats.org/drawingml/2006/main"/>
           <a:p xmlns:a="http://schemas.openxmlformats.org/drawingml/2006/main">
             <a:pPr algn="l">
+              <a:buNone/>
               <a:defRPr sz="825" b="0" i="0">
                 <a:solidFill>
                   <a:srgbClr val="6F746E"/>
@@ -7244,6 +7318,7 @@
           <a:lstStyle xmlns:a="http://schemas.openxmlformats.org/drawingml/2006/main"/>
           <a:p xmlns:a="http://schemas.openxmlformats.org/drawingml/2006/main">
             <a:pPr algn="l">
+              <a:buNone/>
               <a:defRPr sz="750" b="1" i="0">
                 <a:solidFill>
                   <a:srgbClr val="6F746E"/>
@@ -7302,6 +7377,7 @@
           <a:lstStyle xmlns:a="http://schemas.openxmlformats.org/drawingml/2006/main"/>
           <a:p xmlns:a="http://schemas.openxmlformats.org/drawingml/2006/main">
             <a:pPr algn="l">
+              <a:buNone/>
               <a:defRPr sz="2250" b="1" i="0">
                 <a:solidFill>
                   <a:srgbClr val="D94B32"/>
@@ -7360,6 +7436,7 @@
           <a:lstStyle xmlns:a="http://schemas.openxmlformats.org/drawingml/2006/main"/>
           <a:p xmlns:a="http://schemas.openxmlformats.org/drawingml/2006/main">
             <a:pPr algn="l">
+              <a:buNone/>
               <a:defRPr sz="825" b="0" i="0">
                 <a:solidFill>
                   <a:srgbClr val="6F746E"/>
@@ -7453,6 +7530,7 @@
           <a:lstStyle xmlns:a="http://schemas.openxmlformats.org/drawingml/2006/main"/>
           <a:p xmlns:a="http://schemas.openxmlformats.org/drawingml/2006/main">
             <a:pPr algn="l">
+              <a:buNone/>
               <a:defRPr sz="750" b="1" i="0">
                 <a:solidFill>
                   <a:srgbClr val="6F746E"/>
@@ -7511,6 +7589,7 @@
           <a:lstStyle xmlns:a="http://schemas.openxmlformats.org/drawingml/2006/main"/>
           <a:p xmlns:a="http://schemas.openxmlformats.org/drawingml/2006/main">
             <a:pPr algn="l">
+              <a:buNone/>
               <a:defRPr sz="2250" b="1" i="0">
                 <a:solidFill>
                   <a:srgbClr val="E8B64B"/>
@@ -7569,6 +7648,7 @@
           <a:lstStyle xmlns:a="http://schemas.openxmlformats.org/drawingml/2006/main"/>
           <a:p xmlns:a="http://schemas.openxmlformats.org/drawingml/2006/main">
             <a:pPr algn="l">
+              <a:buNone/>
               <a:defRPr sz="825" b="0" i="0">
                 <a:solidFill>
                   <a:srgbClr val="6F746E"/>
@@ -7662,6 +7742,7 @@
           <a:lstStyle xmlns:a="http://schemas.openxmlformats.org/drawingml/2006/main"/>
           <a:p xmlns:a="http://schemas.openxmlformats.org/drawingml/2006/main">
             <a:pPr algn="l">
+              <a:buNone/>
               <a:defRPr sz="750" b="1" i="0">
                 <a:solidFill>
                   <a:srgbClr val="6F746E"/>
@@ -7720,6 +7801,7 @@
           <a:lstStyle xmlns:a="http://schemas.openxmlformats.org/drawingml/2006/main"/>
           <a:p xmlns:a="http://schemas.openxmlformats.org/drawingml/2006/main">
             <a:pPr algn="l">
+              <a:buNone/>
               <a:defRPr sz="1650" b="1" i="0">
                 <a:solidFill>
                   <a:srgbClr val="17211D"/>
@@ -7778,6 +7860,7 @@
           <a:lstStyle xmlns:a="http://schemas.openxmlformats.org/drawingml/2006/main"/>
           <a:p xmlns:a="http://schemas.openxmlformats.org/drawingml/2006/main">
             <a:pPr algn="l">
+              <a:buNone/>
               <a:defRPr sz="975" b="0" i="0">
                 <a:solidFill>
                   <a:srgbClr val="17211D"/>
@@ -7795,7 +7878,7 @@
                 <a:latin typeface="Avenir Next"/>
                 <a:ea typeface="Avenir Next"/>
                 <a:cs typeface="Avenir Next"/>
-                <a:hlinkClick xmlns:r="http://schemas.openxmlformats.org/officeDocument/2006/relationships" r:id="R639ac84a0d634624"/>
+                <a:hlinkClick xmlns:r="http://schemas.openxmlformats.org/officeDocument/2006/relationships" r:id="R35c445c55cfe415e"/>
               </a:rPr>
               <a:t>View verified contract and deployment transaction on Arcscan ↗</a:t>
             </a:r>
@@ -7837,6 +7920,7 @@
           <a:lstStyle xmlns:a="http://schemas.openxmlformats.org/drawingml/2006/main"/>
           <a:p xmlns:a="http://schemas.openxmlformats.org/drawingml/2006/main">
             <a:pPr algn="l">
+              <a:buNone/>
               <a:defRPr sz="750" b="1" i="0">
                 <a:solidFill>
                   <a:srgbClr val="6F746E"/>
@@ -7895,6 +7979,7 @@
           <a:lstStyle xmlns:a="http://schemas.openxmlformats.org/drawingml/2006/main"/>
           <a:p xmlns:a="http://schemas.openxmlformats.org/drawingml/2006/main">
             <a:pPr algn="l">
+              <a:buNone/>
               <a:defRPr sz="1275" b="1" i="0">
                 <a:solidFill>
                   <a:srgbClr val="17211D"/>
@@ -7953,6 +8038,7 @@
           <a:lstStyle xmlns:a="http://schemas.openxmlformats.org/drawingml/2006/main"/>
           <a:p xmlns:a="http://schemas.openxmlformats.org/drawingml/2006/main">
             <a:pPr algn="l">
+              <a:buNone/>
               <a:defRPr sz="900" b="0" i="0">
                 <a:solidFill>
                   <a:srgbClr val="6F746E"/>
@@ -8011,6 +8097,7 @@
           <a:lstStyle xmlns:a="http://schemas.openxmlformats.org/drawingml/2006/main"/>
           <a:p xmlns:a="http://schemas.openxmlformats.org/drawingml/2006/main">
             <a:pPr algn="l">
+              <a:buNone/>
               <a:defRPr sz="675" b="1" i="0">
                 <a:solidFill>
                   <a:srgbClr val="6F746E"/>
@@ -8069,6 +8156,7 @@
           <a:lstStyle xmlns:a="http://schemas.openxmlformats.org/drawingml/2006/main"/>
           <a:p xmlns:a="http://schemas.openxmlformats.org/drawingml/2006/main">
             <a:pPr algn="r">
+              <a:buNone/>
               <a:defRPr sz="675" b="1" i="0">
                 <a:solidFill>
                   <a:srgbClr val="6F746E"/>
@@ -8187,6 +8275,7 @@
           <a:lstStyle xmlns:a="http://schemas.openxmlformats.org/drawingml/2006/main"/>
           <a:p xmlns:a="http://schemas.openxmlformats.org/drawingml/2006/main">
             <a:pPr algn="ctr">
+              <a:buNone/>
               <a:defRPr sz="675" b="1" i="0">
                 <a:solidFill>
                   <a:srgbClr val="FFFDF8"/>
@@ -8245,6 +8334,7 @@
           <a:lstStyle xmlns:a="http://schemas.openxmlformats.org/drawingml/2006/main"/>
           <a:p xmlns:a="http://schemas.openxmlformats.org/drawingml/2006/main">
             <a:pPr algn="l">
+              <a:buNone/>
               <a:defRPr sz="1200" b="1" i="0">
                 <a:solidFill>
                   <a:srgbClr val="17211D"/>
@@ -8303,6 +8393,7 @@
           <a:lstStyle xmlns:a="http://schemas.openxmlformats.org/drawingml/2006/main"/>
           <a:p xmlns:a="http://schemas.openxmlformats.org/drawingml/2006/main">
             <a:pPr algn="r">
+              <a:buNone/>
               <a:defRPr sz="900" b="1" i="0">
                 <a:solidFill>
                   <a:srgbClr val="6F746E"/>
@@ -8361,6 +8452,7 @@
           <a:lstStyle xmlns:a="http://schemas.openxmlformats.org/drawingml/2006/main"/>
           <a:p xmlns:a="http://schemas.openxmlformats.org/drawingml/2006/main">
             <a:pPr algn="l">
+              <a:buNone/>
               <a:defRPr sz="825" b="1" i="0">
                 <a:solidFill>
                   <a:srgbClr val="D94B32"/>
@@ -8419,6 +8511,7 @@
           <a:lstStyle xmlns:a="http://schemas.openxmlformats.org/drawingml/2006/main"/>
           <a:p xmlns:a="http://schemas.openxmlformats.org/drawingml/2006/main">
             <a:pPr algn="l">
+              <a:buNone/>
               <a:defRPr sz="3450" b="1" i="0">
                 <a:solidFill>
                   <a:srgbClr val="17211D"/>
@@ -8477,6 +8570,7 @@
           <a:lstStyle xmlns:a="http://schemas.openxmlformats.org/drawingml/2006/main"/>
           <a:p xmlns:a="http://schemas.openxmlformats.org/drawingml/2006/main">
             <a:pPr algn="l">
+              <a:buNone/>
               <a:defRPr sz="1350" b="1" i="0">
                 <a:solidFill>
                   <a:srgbClr val="17211D"/>
@@ -8568,6 +8662,7 @@
           <a:lstStyle xmlns:a="http://schemas.openxmlformats.org/drawingml/2006/main"/>
           <a:p xmlns:a="http://schemas.openxmlformats.org/drawingml/2006/main">
             <a:pPr algn="ctr">
+              <a:buNone/>
               <a:defRPr sz="825" b="1" i="0">
                 <a:solidFill>
                   <a:srgbClr val="FFFDF8"/>
@@ -8626,6 +8721,7 @@
           <a:lstStyle xmlns:a="http://schemas.openxmlformats.org/drawingml/2006/main"/>
           <a:p xmlns:a="http://schemas.openxmlformats.org/drawingml/2006/main">
             <a:pPr algn="l">
+              <a:buNone/>
               <a:defRPr sz="1050" b="0" i="0">
                 <a:solidFill>
                   <a:srgbClr val="6F746E"/>
@@ -8715,6 +8811,7 @@
           <a:lstStyle xmlns:a="http://schemas.openxmlformats.org/drawingml/2006/main"/>
           <a:p xmlns:a="http://schemas.openxmlformats.org/drawingml/2006/main">
             <a:pPr algn="l">
+              <a:buNone/>
               <a:defRPr sz="1350" b="1" i="0">
                 <a:solidFill>
                   <a:srgbClr val="17211D"/>
@@ -8806,6 +8903,7 @@
           <a:lstStyle xmlns:a="http://schemas.openxmlformats.org/drawingml/2006/main"/>
           <a:p xmlns:a="http://schemas.openxmlformats.org/drawingml/2006/main">
             <a:pPr algn="ctr">
+              <a:buNone/>
               <a:defRPr sz="825" b="1" i="0">
                 <a:solidFill>
                   <a:srgbClr val="FFFDF8"/>
@@ -8864,6 +8962,7 @@
           <a:lstStyle xmlns:a="http://schemas.openxmlformats.org/drawingml/2006/main"/>
           <a:p xmlns:a="http://schemas.openxmlformats.org/drawingml/2006/main">
             <a:pPr algn="l">
+              <a:buNone/>
               <a:defRPr sz="1050" b="0" i="0">
                 <a:solidFill>
                   <a:srgbClr val="6F746E"/>
@@ -8953,6 +9052,7 @@
           <a:lstStyle xmlns:a="http://schemas.openxmlformats.org/drawingml/2006/main"/>
           <a:p xmlns:a="http://schemas.openxmlformats.org/drawingml/2006/main">
             <a:pPr algn="l">
+              <a:buNone/>
               <a:defRPr sz="1350" b="1" i="0">
                 <a:solidFill>
                   <a:srgbClr val="17211D"/>
@@ -9044,6 +9144,7 @@
           <a:lstStyle xmlns:a="http://schemas.openxmlformats.org/drawingml/2006/main"/>
           <a:p xmlns:a="http://schemas.openxmlformats.org/drawingml/2006/main">
             <a:pPr algn="ctr">
+              <a:buNone/>
               <a:defRPr sz="825" b="1" i="0">
                 <a:solidFill>
                   <a:srgbClr val="FFFDF8"/>
@@ -9102,6 +9203,7 @@
           <a:lstStyle xmlns:a="http://schemas.openxmlformats.org/drawingml/2006/main"/>
           <a:p xmlns:a="http://schemas.openxmlformats.org/drawingml/2006/main">
             <a:pPr algn="l">
+              <a:buNone/>
               <a:defRPr sz="1050" b="0" i="0">
                 <a:solidFill>
                   <a:srgbClr val="6F746E"/>
@@ -9191,6 +9293,7 @@
           <a:lstStyle xmlns:a="http://schemas.openxmlformats.org/drawingml/2006/main"/>
           <a:p xmlns:a="http://schemas.openxmlformats.org/drawingml/2006/main">
             <a:pPr algn="l">
+              <a:buNone/>
               <a:defRPr sz="1350" b="1" i="0">
                 <a:solidFill>
                   <a:srgbClr val="17211D"/>
@@ -9282,6 +9385,7 @@
           <a:lstStyle xmlns:a="http://schemas.openxmlformats.org/drawingml/2006/main"/>
           <a:p xmlns:a="http://schemas.openxmlformats.org/drawingml/2006/main">
             <a:pPr algn="ctr">
+              <a:buNone/>
               <a:defRPr sz="825" b="1" i="0">
                 <a:solidFill>
                   <a:srgbClr val="17211D"/>
@@ -9340,6 +9444,7 @@
           <a:lstStyle xmlns:a="http://schemas.openxmlformats.org/drawingml/2006/main"/>
           <a:p xmlns:a="http://schemas.openxmlformats.org/drawingml/2006/main">
             <a:pPr algn="l">
+              <a:buNone/>
               <a:defRPr sz="1050" b="0" i="0">
                 <a:solidFill>
                   <a:srgbClr val="6F746E"/>
@@ -9398,6 +9503,7 @@
           <a:lstStyle xmlns:a="http://schemas.openxmlformats.org/drawingml/2006/main"/>
           <a:p xmlns:a="http://schemas.openxmlformats.org/drawingml/2006/main">
             <a:pPr algn="l">
+              <a:buNone/>
               <a:defRPr sz="975" b="0" i="0">
                 <a:solidFill>
                   <a:srgbClr val="17211D"/>
@@ -9426,7 +9532,7 @@
                 <a:latin typeface="Avenir Next"/>
                 <a:ea typeface="Avenir Next"/>
                 <a:cs typeface="Avenir Next"/>
-                <a:hlinkClick xmlns:r="http://schemas.openxmlformats.org/officeDocument/2006/relationships" r:id="R1a65b75b2ac34dfd"/>
+                <a:hlinkClick xmlns:r="http://schemas.openxmlformats.org/officeDocument/2006/relationships" r:id="Ra8d5ddea28c74af7"/>
               </a:rPr>
               <a:t>github.com/vybao39-rgb/porkpay</a:t>
             </a:r>
@@ -9468,6 +9574,7 @@
           <a:lstStyle xmlns:a="http://schemas.openxmlformats.org/drawingml/2006/main"/>
           <a:p xmlns:a="http://schemas.openxmlformats.org/drawingml/2006/main">
             <a:pPr algn="l">
+              <a:buNone/>
               <a:defRPr sz="675" b="1" i="0">
                 <a:solidFill>
                   <a:srgbClr val="6F746E"/>
@@ -9526,6 +9633,7 @@
           <a:lstStyle xmlns:a="http://schemas.openxmlformats.org/drawingml/2006/main"/>
           <a:p xmlns:a="http://schemas.openxmlformats.org/drawingml/2006/main">
             <a:pPr algn="r">
+              <a:buNone/>
               <a:defRPr sz="675" b="1" i="0">
                 <a:solidFill>
                   <a:srgbClr val="6F746E"/>
@@ -9644,6 +9752,7 @@
           <a:lstStyle xmlns:a="http://schemas.openxmlformats.org/drawingml/2006/main"/>
           <a:p xmlns:a="http://schemas.openxmlformats.org/drawingml/2006/main">
             <a:pPr algn="ctr">
+              <a:buNone/>
               <a:defRPr sz="675" b="1" i="0">
                 <a:solidFill>
                   <a:srgbClr val="FFFDF8"/>
@@ -9702,6 +9811,7 @@
           <a:lstStyle xmlns:a="http://schemas.openxmlformats.org/drawingml/2006/main"/>
           <a:p xmlns:a="http://schemas.openxmlformats.org/drawingml/2006/main">
             <a:pPr algn="l">
+              <a:buNone/>
               <a:defRPr sz="1200" b="1" i="0">
                 <a:solidFill>
                   <a:srgbClr val="17211D"/>
@@ -9760,6 +9870,7 @@
           <a:lstStyle xmlns:a="http://schemas.openxmlformats.org/drawingml/2006/main"/>
           <a:p xmlns:a="http://schemas.openxmlformats.org/drawingml/2006/main">
             <a:pPr algn="r">
+              <a:buNone/>
               <a:defRPr sz="900" b="1" i="0">
                 <a:solidFill>
                   <a:srgbClr val="6F746E"/>
@@ -9818,6 +9929,7 @@
           <a:lstStyle xmlns:a="http://schemas.openxmlformats.org/drawingml/2006/main"/>
           <a:p xmlns:a="http://schemas.openxmlformats.org/drawingml/2006/main">
             <a:pPr algn="l">
+              <a:buNone/>
               <a:defRPr sz="825" b="1" i="0">
                 <a:solidFill>
                   <a:srgbClr val="D94B32"/>
@@ -9876,6 +9988,7 @@
           <a:lstStyle xmlns:a="http://schemas.openxmlformats.org/drawingml/2006/main"/>
           <a:p xmlns:a="http://schemas.openxmlformats.org/drawingml/2006/main">
             <a:pPr algn="l">
+              <a:buNone/>
               <a:defRPr sz="3450" b="1" i="0">
                 <a:solidFill>
                   <a:srgbClr val="17211D"/>
@@ -9969,6 +10082,7 @@
           <a:lstStyle xmlns:a="http://schemas.openxmlformats.org/drawingml/2006/main"/>
           <a:p xmlns:a="http://schemas.openxmlformats.org/drawingml/2006/main">
             <a:pPr algn="ctr">
+              <a:buNone/>
               <a:defRPr sz="825" b="1" i="0">
                 <a:solidFill>
                   <a:srgbClr val="0C665A"/>
@@ -10027,6 +10141,7 @@
           <a:lstStyle xmlns:a="http://schemas.openxmlformats.org/drawingml/2006/main"/>
           <a:p xmlns:a="http://schemas.openxmlformats.org/drawingml/2006/main">
             <a:pPr algn="ctr">
+              <a:buNone/>
               <a:defRPr sz="900" b="0" i="0">
                 <a:solidFill>
                   <a:srgbClr val="17211D"/>
@@ -10045,7 +10160,7 @@
                 <a:ea typeface="Avenir Next"/>
                 <a:cs typeface="Avenir Next"/>
               </a:rPr>
-              <a:t>Signs payment, request and repayment</a:t>
+              <a:t>Signs login proof (no gas), payment and repayment</a:t>
             </a:r>
           </a:p>
         </p:txBody>
@@ -10147,6 +10262,7 @@
           <a:lstStyle xmlns:a="http://schemas.openxmlformats.org/drawingml/2006/main"/>
           <a:p xmlns:a="http://schemas.openxmlformats.org/drawingml/2006/main">
             <a:pPr algn="ctr">
+              <a:buNone/>
               <a:defRPr sz="750" b="1" i="0">
                 <a:solidFill>
                   <a:srgbClr val="FFFDF8"/>
@@ -10240,6 +10356,7 @@
           <a:lstStyle xmlns:a="http://schemas.openxmlformats.org/drawingml/2006/main"/>
           <a:p xmlns:a="http://schemas.openxmlformats.org/drawingml/2006/main">
             <a:pPr algn="ctr">
+              <a:buNone/>
               <a:defRPr sz="825" b="1" i="0">
                 <a:solidFill>
                   <a:srgbClr val="0C665A"/>
@@ -10298,6 +10415,7 @@
           <a:lstStyle xmlns:a="http://schemas.openxmlformats.org/drawingml/2006/main"/>
           <a:p xmlns:a="http://schemas.openxmlformats.org/drawingml/2006/main">
             <a:pPr algn="ctr">
+              <a:buNone/>
               <a:defRPr sz="900" b="0" i="0">
                 <a:solidFill>
                   <a:srgbClr val="17211D"/>
@@ -10418,6 +10536,7 @@
           <a:lstStyle xmlns:a="http://schemas.openxmlformats.org/drawingml/2006/main"/>
           <a:p xmlns:a="http://schemas.openxmlformats.org/drawingml/2006/main">
             <a:pPr algn="ctr">
+              <a:buNone/>
               <a:defRPr sz="750" b="1" i="0">
                 <a:solidFill>
                   <a:srgbClr val="FFFDF8"/>
@@ -10511,6 +10630,7 @@
           <a:lstStyle xmlns:a="http://schemas.openxmlformats.org/drawingml/2006/main"/>
           <a:p xmlns:a="http://schemas.openxmlformats.org/drawingml/2006/main">
             <a:pPr algn="ctr">
+              <a:buNone/>
               <a:defRPr sz="825" b="1" i="0">
                 <a:solidFill>
                   <a:srgbClr val="0C665A"/>
@@ -10569,6 +10689,7 @@
           <a:lstStyle xmlns:a="http://schemas.openxmlformats.org/drawingml/2006/main"/>
           <a:p xmlns:a="http://schemas.openxmlformats.org/drawingml/2006/main">
             <a:pPr algn="ctr">
+              <a:buNone/>
               <a:defRPr sz="900" b="0" i="0">
                 <a:solidFill>
                   <a:srgbClr val="17211D"/>
@@ -10689,6 +10810,7 @@
           <a:lstStyle xmlns:a="http://schemas.openxmlformats.org/drawingml/2006/main"/>
           <a:p xmlns:a="http://schemas.openxmlformats.org/drawingml/2006/main">
             <a:pPr algn="ctr">
+              <a:buNone/>
               <a:defRPr sz="750" b="1" i="0">
                 <a:solidFill>
                   <a:srgbClr val="FFFDF8"/>
@@ -10782,6 +10904,7 @@
           <a:lstStyle xmlns:a="http://schemas.openxmlformats.org/drawingml/2006/main"/>
           <a:p xmlns:a="http://schemas.openxmlformats.org/drawingml/2006/main">
             <a:pPr algn="ctr">
+              <a:buNone/>
               <a:defRPr sz="825" b="1" i="0">
                 <a:solidFill>
                   <a:srgbClr val="805B00"/>
@@ -10840,6 +10963,7 @@
           <a:lstStyle xmlns:a="http://schemas.openxmlformats.org/drawingml/2006/main"/>
           <a:p xmlns:a="http://schemas.openxmlformats.org/drawingml/2006/main">
             <a:pPr algn="ctr">
+              <a:buNone/>
               <a:defRPr sz="900" b="0" i="0">
                 <a:solidFill>
                   <a:srgbClr val="17211D"/>
@@ -10960,6 +11084,7 @@
           <a:lstStyle xmlns:a="http://schemas.openxmlformats.org/drawingml/2006/main"/>
           <a:p xmlns:a="http://schemas.openxmlformats.org/drawingml/2006/main">
             <a:pPr algn="ctr">
+              <a:buNone/>
               <a:defRPr sz="750" b="1" i="0">
                 <a:solidFill>
                   <a:srgbClr val="FFFDF8"/>
@@ -11053,6 +11178,7 @@
           <a:lstStyle xmlns:a="http://schemas.openxmlformats.org/drawingml/2006/main"/>
           <a:p xmlns:a="http://schemas.openxmlformats.org/drawingml/2006/main">
             <a:pPr algn="ctr">
+              <a:buNone/>
               <a:defRPr sz="825" b="1" i="0">
                 <a:solidFill>
                   <a:srgbClr val="D94B32"/>
@@ -11111,6 +11237,7 @@
           <a:lstStyle xmlns:a="http://schemas.openxmlformats.org/drawingml/2006/main"/>
           <a:p xmlns:a="http://schemas.openxmlformats.org/drawingml/2006/main">
             <a:pPr algn="ctr">
+              <a:buNone/>
               <a:defRPr sz="900" b="0" i="0">
                 <a:solidFill>
                   <a:srgbClr val="17211D"/>
@@ -11169,6 +11296,7 @@
           <a:lstStyle xmlns:a="http://schemas.openxmlformats.org/drawingml/2006/main"/>
           <a:p xmlns:a="http://schemas.openxmlformats.org/drawingml/2006/main">
             <a:pPr algn="l">
+              <a:buNone/>
               <a:defRPr sz="750" b="1" i="0">
                 <a:solidFill>
                   <a:srgbClr val="D94B32"/>
@@ -11227,6 +11355,7 @@
           <a:lstStyle xmlns:a="http://schemas.openxmlformats.org/drawingml/2006/main"/>
           <a:p xmlns:a="http://schemas.openxmlformats.org/drawingml/2006/main">
             <a:pPr algn="l">
+              <a:buNone/>
               <a:defRPr sz="975" b="0" i="0">
                 <a:solidFill>
                   <a:srgbClr val="6F746E"/>
@@ -11285,6 +11414,7 @@
           <a:lstStyle xmlns:a="http://schemas.openxmlformats.org/drawingml/2006/main"/>
           <a:p xmlns:a="http://schemas.openxmlformats.org/drawingml/2006/main">
             <a:pPr algn="l">
+              <a:buNone/>
               <a:defRPr sz="750" b="1" i="0">
                 <a:solidFill>
                   <a:srgbClr val="D94B32"/>
@@ -11343,6 +11473,7 @@
           <a:lstStyle xmlns:a="http://schemas.openxmlformats.org/drawingml/2006/main"/>
           <a:p xmlns:a="http://schemas.openxmlformats.org/drawingml/2006/main">
             <a:pPr algn="l">
+              <a:buNone/>
               <a:defRPr sz="975" b="0" i="0">
                 <a:solidFill>
                   <a:srgbClr val="6F746E"/>
@@ -11401,6 +11532,7 @@
           <a:lstStyle xmlns:a="http://schemas.openxmlformats.org/drawingml/2006/main"/>
           <a:p xmlns:a="http://schemas.openxmlformats.org/drawingml/2006/main">
             <a:pPr algn="l">
+              <a:buNone/>
               <a:defRPr sz="750" b="1" i="0">
                 <a:solidFill>
                   <a:srgbClr val="D94B32"/>
@@ -11459,6 +11591,7 @@
           <a:lstStyle xmlns:a="http://schemas.openxmlformats.org/drawingml/2006/main"/>
           <a:p xmlns:a="http://schemas.openxmlformats.org/drawingml/2006/main">
             <a:pPr algn="l">
+              <a:buNone/>
               <a:defRPr sz="975" b="0" i="0">
                 <a:solidFill>
                   <a:srgbClr val="6F746E"/>
@@ -11517,6 +11650,7 @@
           <a:lstStyle xmlns:a="http://schemas.openxmlformats.org/drawingml/2006/main"/>
           <a:p xmlns:a="http://schemas.openxmlformats.org/drawingml/2006/main">
             <a:pPr algn="l">
+              <a:buNone/>
               <a:defRPr sz="675" b="1" i="0">
                 <a:solidFill>
                   <a:srgbClr val="6F746E"/>
@@ -11575,6 +11709,7 @@
           <a:lstStyle xmlns:a="http://schemas.openxmlformats.org/drawingml/2006/main"/>
           <a:p xmlns:a="http://schemas.openxmlformats.org/drawingml/2006/main">
             <a:pPr algn="r">
+              <a:buNone/>
               <a:defRPr sz="675" b="1" i="0">
                 <a:solidFill>
                   <a:srgbClr val="6F746E"/>
@@ -11724,6 +11859,7 @@
           <a:lstStyle xmlns:a="http://schemas.openxmlformats.org/drawingml/2006/main"/>
           <a:p xmlns:a="http://schemas.openxmlformats.org/drawingml/2006/main">
             <a:pPr algn="ctr">
+              <a:buNone/>
               <a:defRPr sz="900" b="1" i="0">
                 <a:solidFill>
                   <a:srgbClr val="FFFDF8"/>
@@ -11782,6 +11918,7 @@
           <a:lstStyle xmlns:a="http://schemas.openxmlformats.org/drawingml/2006/main"/>
           <a:p xmlns:a="http://schemas.openxmlformats.org/drawingml/2006/main">
             <a:pPr algn="l">
+              <a:buNone/>
               <a:defRPr sz="825" b="1" i="0">
                 <a:solidFill>
                   <a:srgbClr val="FFECE6"/>
@@ -11840,6 +11977,7 @@
           <a:lstStyle xmlns:a="http://schemas.openxmlformats.org/drawingml/2006/main"/>
           <a:p xmlns:a="http://schemas.openxmlformats.org/drawingml/2006/main">
             <a:pPr algn="l">
+              <a:buNone/>
               <a:defRPr sz="3900" b="1" i="0">
                 <a:solidFill>
                   <a:srgbClr val="FFFDF8"/>
@@ -11863,6 +12001,7 @@
           </a:p>
           <a:p xmlns:a="http://schemas.openxmlformats.org/drawingml/2006/main">
             <a:pPr algn="l">
+              <a:buNone/>
               <a:defRPr sz="3900" b="1" i="0">
                 <a:solidFill>
                   <a:srgbClr val="FFFDF8"/>
@@ -11921,6 +12060,7 @@
           <a:lstStyle xmlns:a="http://schemas.openxmlformats.org/drawingml/2006/main"/>
           <a:p xmlns:a="http://schemas.openxmlformats.org/drawingml/2006/main">
             <a:pPr algn="l">
+              <a:buNone/>
               <a:defRPr sz="1350" b="0" i="0">
                 <a:solidFill>
                   <a:srgbClr val="FFECE6"/>
@@ -12012,6 +12152,7 @@
           <a:lstStyle xmlns:a="http://schemas.openxmlformats.org/drawingml/2006/main"/>
           <a:p xmlns:a="http://schemas.openxmlformats.org/drawingml/2006/main">
             <a:pPr algn="ctr">
+              <a:buNone/>
               <a:defRPr sz="825" b="1" i="0">
                 <a:solidFill>
                   <a:srgbClr val="FFFDF8"/>
@@ -12070,6 +12211,7 @@
           <a:lstStyle xmlns:a="http://schemas.openxmlformats.org/drawingml/2006/main"/>
           <a:p xmlns:a="http://schemas.openxmlformats.org/drawingml/2006/main">
             <a:pPr algn="l">
+              <a:buNone/>
               <a:defRPr sz="750" b="1" i="0">
                 <a:solidFill>
                   <a:srgbClr val="D94B32"/>
@@ -12128,6 +12270,7 @@
           <a:lstStyle xmlns:a="http://schemas.openxmlformats.org/drawingml/2006/main"/>
           <a:p xmlns:a="http://schemas.openxmlformats.org/drawingml/2006/main">
             <a:pPr algn="l">
+              <a:buNone/>
               <a:defRPr sz="900" b="0" i="0">
                 <a:solidFill>
                   <a:srgbClr val="17211D"/>
@@ -12145,7 +12288,7 @@
                 <a:latin typeface="Avenir Next"/>
                 <a:ea typeface="Avenir Next"/>
                 <a:cs typeface="Avenir Next"/>
-                <a:hlinkClick xmlns:r="http://schemas.openxmlformats.org/officeDocument/2006/relationships" r:id="R9a2334681dc14ec6"/>
+                <a:hlinkClick xmlns:r="http://schemas.openxmlformats.org/officeDocument/2006/relationships" r:id="R40991c35411b4242"/>
               </a:rPr>
               <a:t>https://vpork.xyz/</a:t>
             </a:r>
@@ -12218,6 +12361,7 @@
           <a:lstStyle xmlns:a="http://schemas.openxmlformats.org/drawingml/2006/main"/>
           <a:p xmlns:a="http://schemas.openxmlformats.org/drawingml/2006/main">
             <a:pPr algn="l">
+              <a:buNone/>
               <a:defRPr sz="750" b="1" i="0">
                 <a:solidFill>
                   <a:srgbClr val="D94B32"/>
@@ -12276,6 +12420,7 @@
           <a:lstStyle xmlns:a="http://schemas.openxmlformats.org/drawingml/2006/main"/>
           <a:p xmlns:a="http://schemas.openxmlformats.org/drawingml/2006/main">
             <a:pPr algn="l">
+              <a:buNone/>
               <a:defRPr sz="900" b="0" i="0">
                 <a:solidFill>
                   <a:srgbClr val="17211D"/>
@@ -12293,7 +12438,7 @@
                 <a:latin typeface="Avenir Next"/>
                 <a:ea typeface="Avenir Next"/>
                 <a:cs typeface="Avenir Next"/>
-                <a:hlinkClick xmlns:r="http://schemas.openxmlformats.org/officeDocument/2006/relationships" r:id="R1760d289fc37436c"/>
+                <a:hlinkClick xmlns:r="http://schemas.openxmlformats.org/officeDocument/2006/relationships" r:id="Raee2901f39d543f8"/>
               </a:rPr>
               <a:t>https://github.com/vybao39-rgb/porkpay</a:t>
             </a:r>
@@ -12366,6 +12511,7 @@
           <a:lstStyle xmlns:a="http://schemas.openxmlformats.org/drawingml/2006/main"/>
           <a:p xmlns:a="http://schemas.openxmlformats.org/drawingml/2006/main">
             <a:pPr algn="l">
+              <a:buNone/>
               <a:defRPr sz="750" b="1" i="0">
                 <a:solidFill>
                   <a:srgbClr val="D94B32"/>
@@ -12424,6 +12570,7 @@
           <a:lstStyle xmlns:a="http://schemas.openxmlformats.org/drawingml/2006/main"/>
           <a:p xmlns:a="http://schemas.openxmlformats.org/drawingml/2006/main">
             <a:pPr algn="l">
+              <a:buNone/>
               <a:defRPr sz="900" b="0" i="0">
                 <a:solidFill>
                   <a:srgbClr val="17211D"/>
@@ -12441,7 +12588,7 @@
                 <a:latin typeface="Avenir Next"/>
                 <a:ea typeface="Avenir Next"/>
                 <a:cs typeface="Avenir Next"/>
-                <a:hlinkClick xmlns:r="http://schemas.openxmlformats.org/officeDocument/2006/relationships" r:id="R10a738bb4879448f"/>
+                <a:hlinkClick xmlns:r="http://schemas.openxmlformats.org/officeDocument/2006/relationships" r:id="R661a192b306f4fc5"/>
               </a:rPr>
               <a:t>https://vpork.xyz/VPorkPay-Final-Demo.mp4</a:t>
             </a:r>
@@ -12514,6 +12661,7 @@
           <a:lstStyle xmlns:a="http://schemas.openxmlformats.org/drawingml/2006/main"/>
           <a:p xmlns:a="http://schemas.openxmlformats.org/drawingml/2006/main">
             <a:pPr algn="l">
+              <a:buNone/>
               <a:defRPr sz="750" b="1" i="0">
                 <a:solidFill>
                   <a:srgbClr val="D94B32"/>
@@ -12572,6 +12720,7 @@
           <a:lstStyle xmlns:a="http://schemas.openxmlformats.org/drawingml/2006/main"/>
           <a:p xmlns:a="http://schemas.openxmlformats.org/drawingml/2006/main">
             <a:pPr algn="l">
+              <a:buNone/>
               <a:defRPr sz="900" b="0" i="0">
                 <a:solidFill>
                   <a:srgbClr val="17211D"/>
@@ -12589,7 +12738,7 @@
                 <a:latin typeface="Avenir Next"/>
                 <a:ea typeface="Avenir Next"/>
                 <a:cs typeface="Avenir Next"/>
-                <a:hlinkClick xmlns:r="http://schemas.openxmlformats.org/officeDocument/2006/relationships" r:id="R52bc9928bfcf4bb3"/>
+                <a:hlinkClick xmlns:r="http://schemas.openxmlformats.org/officeDocument/2006/relationships" r:id="R5e696ea1a2e84dac"/>
               </a:rPr>
               <a:t>https://vpork.xyz/VPorkPay-Final-Submission-Deck.pptx</a:t>
             </a:r>
@@ -12662,6 +12811,7 @@
           <a:lstStyle xmlns:a="http://schemas.openxmlformats.org/drawingml/2006/main"/>
           <a:p xmlns:a="http://schemas.openxmlformats.org/drawingml/2006/main">
             <a:pPr algn="l">
+              <a:buNone/>
               <a:defRPr sz="750" b="1" i="0">
                 <a:solidFill>
                   <a:srgbClr val="D94B32"/>
@@ -12720,6 +12870,7 @@
           <a:lstStyle xmlns:a="http://schemas.openxmlformats.org/drawingml/2006/main"/>
           <a:p xmlns:a="http://schemas.openxmlformats.org/drawingml/2006/main">
             <a:pPr algn="l">
+              <a:buNone/>
               <a:defRPr sz="900" b="0" i="0">
                 <a:solidFill>
                   <a:srgbClr val="17211D"/>
@@ -12737,7 +12888,7 @@
                 <a:latin typeface="Avenir Next"/>
                 <a:ea typeface="Avenir Next"/>
                 <a:cs typeface="Avenir Next"/>
-                <a:hlinkClick xmlns:r="http://schemas.openxmlformats.org/officeDocument/2006/relationships" r:id="R44052e605f834dbb"/>
+                <a:hlinkClick xmlns:r="http://schemas.openxmlformats.org/officeDocument/2006/relationships" r:id="R456052f4c5764fb5"/>
               </a:rPr>
               <a:t>https://vpork.xyz/submission.html</a:t>
             </a:r>
@@ -12779,6 +12930,7 @@
           <a:lstStyle xmlns:a="http://schemas.openxmlformats.org/drawingml/2006/main"/>
           <a:p xmlns:a="http://schemas.openxmlformats.org/drawingml/2006/main">
             <a:pPr algn="l">
+              <a:buNone/>
               <a:defRPr sz="675" b="1" i="0">
                 <a:solidFill>
                   <a:srgbClr val="FFECE6"/>

</xml_diff>